<commit_message>
docs(memo): v3 gains a one-page technical overview, and a layout self-check tool
Adds slide 2 in the internal one-pager format: title bar, challenge/goal split,
then three columns -- the runtime loop as a flowchart, two bordered mechanism
panels (confidence scheduling on the algorithm side, variable-length decode
graph on the engineering side) each closing with a deliverables bar, and a
milestone timeline down the right. The whole proposal is readable from that one
slide; the remaining six expand it. Milestones use T+ offsets rather than
absolute dates, since no start date has been approved.

Also adds preview_pptx.py. There is no LibreOffice in this environment, so every
deck so far has been shipped without anyone having looked at it. The script
redraws a deck from its shape geometry with PIL purely to expose overlaps and
text running past its shape -- it caught three real overflows in this slide that
the coordinate arithmetic had passed.
</commit_message>
<xml_diff>
--- a/docs/memos/adaptive-spec-project-proposal-v3.pptx
+++ b/docs/memos/adaptive-spec-project-proposal-v3.pptx
@@ -12,6 +12,7 @@
     <p:sldId id="260" r:id="rId11"/>
     <p:sldId id="261" r:id="rId12"/>
     <p:sldId id="262" r:id="rId13"/>
+    <p:sldId id="263" r:id="rId14"/>
   </p:sldIdLst>
   <p:sldSz cx="12191695" cy="6858000" type="screen4x3"/>
   <p:notesSz cx="6858000" cy="9144000"/>
@@ -3239,6 +3240,3683 @@
         </p:nvSpPr>
         <p:spPr>
           <a:xfrm>
+            <a:off x="292608" y="128016"/>
+            <a:ext cx="11612880" cy="457200"/>
+          </a:xfrm>
+          <a:prstGeom prst="rect">
+            <a:avLst/>
+          </a:prstGeom>
+          <a:noFill/>
+        </p:spPr>
+        <p:txBody>
+          <a:bodyPr wrap="square">
+            <a:spAutoFit/>
+          </a:bodyPr>
+          <a:lstStyle/>
+          <a:p>
+            <a:pPr algn="l">
+              <a:spcBef>
+                <a:spcPts val="0"/>
+              </a:spcBef>
+              <a:spcAft>
+                <a:spcPts val="0"/>
+              </a:spcAft>
+            </a:pPr>
+            <a:r>
+              <a:rPr sz="2300" b="1">
+                <a:solidFill>
+                  <a:srgbClr val="C00000"/>
+                </a:solidFill>
+                <a:latin typeface="微软雅黑"/>
+                <a:ea typeface="微软雅黑"/>
+              </a:rPr>
+              <a:t>技术点:昇腾 NPU 自适应投机解码 —— 按置信度分配验证预算</a:t>
+            </a:r>
+          </a:p>
+        </p:txBody>
+      </p:sp>
+      <p:sp>
+        <p:nvSpPr>
+          <p:cNvPr id="3" name="Rectangle 2"/>
+          <p:cNvSpPr/>
+          <p:nvPr/>
+        </p:nvSpPr>
+        <p:spPr>
+          <a:xfrm>
+            <a:off x="292608" y="640080"/>
+            <a:ext cx="384048" cy="896112"/>
+          </a:xfrm>
+          <a:prstGeom prst="rect">
+            <a:avLst/>
+          </a:prstGeom>
+          <a:solidFill>
+            <a:srgbClr val="C00000"/>
+          </a:solidFill>
+          <a:ln>
+            <a:noFill/>
+          </a:ln>
+          <a:effectLst/>
+        </p:spPr>
+        <p:style>
+          <a:lnRef idx="1">
+            <a:schemeClr val="accent1"/>
+          </a:lnRef>
+          <a:fillRef idx="3">
+            <a:schemeClr val="accent1"/>
+          </a:fillRef>
+          <a:effectRef idx="2">
+            <a:schemeClr val="accent1"/>
+          </a:effectRef>
+          <a:fontRef idx="minor">
+            <a:schemeClr val="lt1"/>
+          </a:fontRef>
+        </p:style>
+        <p:txBody>
+          <a:bodyPr rtlCol="0" anchor="ctr" wrap="square" lIns="45720" rIns="45720" tIns="18288" bIns="18288"/>
+          <a:lstStyle/>
+          <a:p>
+            <a:pPr algn="ctr">
+              <a:spcBef>
+                <a:spcPts val="0"/>
+              </a:spcBef>
+              <a:spcAft>
+                <a:spcPts val="0"/>
+              </a:spcAft>
+            </a:pPr>
+            <a:r>
+              <a:rPr sz="1200" b="0">
+                <a:solidFill>
+                  <a:srgbClr val="FFFFFF"/>
+                </a:solidFill>
+                <a:latin typeface="微软雅黑"/>
+                <a:ea typeface="微软雅黑"/>
+              </a:rPr>
+              <a:t>挑</a:t>
+            </a:r>
+          </a:p>
+          <a:p>
+            <a:pPr algn="ctr">
+              <a:spcBef>
+                <a:spcPts val="0"/>
+              </a:spcBef>
+              <a:spcAft>
+                <a:spcPts val="0"/>
+              </a:spcAft>
+            </a:pPr>
+            <a:r>
+              <a:rPr sz="1200" b="0">
+                <a:solidFill>
+                  <a:srgbClr val="FFFFFF"/>
+                </a:solidFill>
+                <a:latin typeface="微软雅黑"/>
+                <a:ea typeface="微软雅黑"/>
+              </a:rPr>
+              <a:t>战</a:t>
+            </a:r>
+          </a:p>
+        </p:txBody>
+      </p:sp>
+      <p:sp>
+        <p:nvSpPr>
+          <p:cNvPr id="4" name="Rectangle 3"/>
+          <p:cNvSpPr/>
+          <p:nvPr/>
+        </p:nvSpPr>
+        <p:spPr>
+          <a:xfrm>
+            <a:off x="676656" y="640080"/>
+            <a:ext cx="5138928" cy="896112"/>
+          </a:xfrm>
+          <a:prstGeom prst="rect">
+            <a:avLst/>
+          </a:prstGeom>
+          <a:solidFill>
+            <a:srgbClr val="F2F2F2"/>
+          </a:solidFill>
+          <a:ln>
+            <a:noFill/>
+          </a:ln>
+          <a:effectLst/>
+        </p:spPr>
+        <p:style>
+          <a:lnRef idx="1">
+            <a:schemeClr val="accent1"/>
+          </a:lnRef>
+          <a:fillRef idx="3">
+            <a:schemeClr val="accent1"/>
+          </a:fillRef>
+          <a:effectRef idx="2">
+            <a:schemeClr val="accent1"/>
+          </a:effectRef>
+          <a:fontRef idx="minor">
+            <a:schemeClr val="lt1"/>
+          </a:fontRef>
+        </p:style>
+        <p:txBody>
+          <a:bodyPr rtlCol="0" anchor="ctr" wrap="square" lIns="45720" rIns="45720" tIns="18288" bIns="18288"/>
+          <a:lstStyle/>
+          <a:p>
+            <a:pPr algn="l">
+              <a:spcBef>
+                <a:spcPts val="100"/>
+              </a:spcBef>
+              <a:spcAft>
+                <a:spcPts val="100"/>
+              </a:spcAft>
+            </a:pPr>
+            <a:r>
+              <a:rPr sz="1050" b="0">
+                <a:solidFill>
+                  <a:srgbClr val="1B222E"/>
+                </a:solidFill>
+                <a:latin typeface="微软雅黑"/>
+                <a:ea typeface="微软雅黑"/>
+              </a:rPr>
+              <a:t>· 固定 K 对全 batch 一视同仁 —— 高置信请求本可多验,低置信请求白耗 target 算力</a:t>
+            </a:r>
+          </a:p>
+          <a:p>
+            <a:pPr algn="l">
+              <a:spcBef>
+                <a:spcPts val="100"/>
+              </a:spcBef>
+              <a:spcAft>
+                <a:spcPts val="100"/>
+              </a:spcAft>
+            </a:pPr>
+            <a:r>
+              <a:rPr sz="1050" b="0">
+                <a:solidFill>
+                  <a:srgbClr val="1B222E"/>
+                </a:solidFill>
+                <a:latin typeface="微软雅黑"/>
+                <a:ea typeface="微软雅黑"/>
+              </a:rPr>
+              <a:t>· 变长 K_i 与设备图「形状固定」天然冲突,昇腾当前按固定形状捕获</a:t>
+            </a:r>
+          </a:p>
+          <a:p>
+            <a:pPr algn="l">
+              <a:spcBef>
+                <a:spcPts val="100"/>
+              </a:spcBef>
+              <a:spcAft>
+                <a:spcPts val="100"/>
+              </a:spcAft>
+            </a:pPr>
+            <a:r>
+              <a:rPr sz="1050" b="0">
+                <a:solidFill>
+                  <a:srgbClr val="C00000"/>
+                </a:solidFill>
+                <a:latin typeface="微软雅黑"/>
+                <a:ea typeface="微软雅黑"/>
+              </a:rPr>
+              <a:t>· 昇腾侧 confidence head 根本未被加载,调度所需的信号拿不到</a:t>
+            </a:r>
+          </a:p>
+        </p:txBody>
+      </p:sp>
+      <p:sp>
+        <p:nvSpPr>
+          <p:cNvPr id="5" name="Rectangle 4"/>
+          <p:cNvSpPr/>
+          <p:nvPr/>
+        </p:nvSpPr>
+        <p:spPr>
+          <a:xfrm>
+            <a:off x="6053328" y="640080"/>
+            <a:ext cx="384048" cy="896112"/>
+          </a:xfrm>
+          <a:prstGeom prst="rect">
+            <a:avLst/>
+          </a:prstGeom>
+          <a:solidFill>
+            <a:srgbClr val="C00000"/>
+          </a:solidFill>
+          <a:ln>
+            <a:noFill/>
+          </a:ln>
+          <a:effectLst/>
+        </p:spPr>
+        <p:style>
+          <a:lnRef idx="1">
+            <a:schemeClr val="accent1"/>
+          </a:lnRef>
+          <a:fillRef idx="3">
+            <a:schemeClr val="accent1"/>
+          </a:fillRef>
+          <a:effectRef idx="2">
+            <a:schemeClr val="accent1"/>
+          </a:effectRef>
+          <a:fontRef idx="minor">
+            <a:schemeClr val="lt1"/>
+          </a:fontRef>
+        </p:style>
+        <p:txBody>
+          <a:bodyPr rtlCol="0" anchor="ctr" wrap="square" lIns="45720" rIns="45720" tIns="18288" bIns="18288"/>
+          <a:lstStyle/>
+          <a:p>
+            <a:pPr algn="ctr">
+              <a:spcBef>
+                <a:spcPts val="0"/>
+              </a:spcBef>
+              <a:spcAft>
+                <a:spcPts val="0"/>
+              </a:spcAft>
+            </a:pPr>
+            <a:r>
+              <a:rPr sz="1200" b="0">
+                <a:solidFill>
+                  <a:srgbClr val="FFFFFF"/>
+                </a:solidFill>
+                <a:latin typeface="微软雅黑"/>
+                <a:ea typeface="微软雅黑"/>
+              </a:rPr>
+              <a:t>目</a:t>
+            </a:r>
+          </a:p>
+          <a:p>
+            <a:pPr algn="ctr">
+              <a:spcBef>
+                <a:spcPts val="0"/>
+              </a:spcBef>
+              <a:spcAft>
+                <a:spcPts val="0"/>
+              </a:spcAft>
+            </a:pPr>
+            <a:r>
+              <a:rPr sz="1200" b="0">
+                <a:solidFill>
+                  <a:srgbClr val="FFFFFF"/>
+                </a:solidFill>
+                <a:latin typeface="微软雅黑"/>
+                <a:ea typeface="微软雅黑"/>
+              </a:rPr>
+              <a:t>标</a:t>
+            </a:r>
+          </a:p>
+        </p:txBody>
+      </p:sp>
+      <p:sp>
+        <p:nvSpPr>
+          <p:cNvPr id="6" name="Rectangle 5"/>
+          <p:cNvSpPr/>
+          <p:nvPr/>
+        </p:nvSpPr>
+        <p:spPr>
+          <a:xfrm>
+            <a:off x="6437376" y="640080"/>
+            <a:ext cx="5431536" cy="896112"/>
+          </a:xfrm>
+          <a:prstGeom prst="rect">
+            <a:avLst/>
+          </a:prstGeom>
+          <a:solidFill>
+            <a:srgbClr val="F2F2F2"/>
+          </a:solidFill>
+          <a:ln>
+            <a:noFill/>
+          </a:ln>
+          <a:effectLst/>
+        </p:spPr>
+        <p:style>
+          <a:lnRef idx="1">
+            <a:schemeClr val="accent1"/>
+          </a:lnRef>
+          <a:fillRef idx="3">
+            <a:schemeClr val="accent1"/>
+          </a:fillRef>
+          <a:effectRef idx="2">
+            <a:schemeClr val="accent1"/>
+          </a:effectRef>
+          <a:fontRef idx="minor">
+            <a:schemeClr val="lt1"/>
+          </a:fontRef>
+        </p:style>
+        <p:txBody>
+          <a:bodyPr rtlCol="0" anchor="ctr" wrap="square" lIns="45720" rIns="45720" tIns="18288" bIns="18288"/>
+          <a:lstStyle/>
+          <a:p>
+            <a:pPr algn="l">
+              <a:spcBef>
+                <a:spcPts val="100"/>
+              </a:spcBef>
+              <a:spcAft>
+                <a:spcPts val="100"/>
+              </a:spcAft>
+            </a:pPr>
+            <a:r>
+              <a:rPr sz="1050" b="0">
+                <a:solidFill>
+                  <a:srgbClr val="1B222E"/>
+                </a:solidFill>
+                <a:latin typeface="微软雅黑"/>
+                <a:ea typeface="微软雅黑"/>
+              </a:rPr>
+              <a:t>· 对齐上游 vLLM #47808 机制,在昇腾实现按置信度的验证预算分配</a:t>
+            </a:r>
+          </a:p>
+          <a:p>
+            <a:pPr algn="l">
+              <a:spcBef>
+                <a:spcPts val="100"/>
+              </a:spcBef>
+              <a:spcAft>
+                <a:spcPts val="100"/>
+              </a:spcAft>
+            </a:pPr>
+            <a:r>
+              <a:rPr sz="1050" b="0">
+                <a:solidFill>
+                  <a:srgbClr val="C00000"/>
+                </a:solidFill>
+                <a:latin typeface="微软雅黑"/>
+                <a:ea typeface="微软雅黑"/>
+              </a:rPr>
+              <a:t>· 同等验证预算下提升接受长度 —— 上游实测 +7.6%,收益随 target 变贵而放大</a:t>
+            </a:r>
+          </a:p>
+          <a:p>
+            <a:pPr algn="l">
+              <a:spcBef>
+                <a:spcPts val="100"/>
+              </a:spcBef>
+              <a:spcAft>
+                <a:spcPts val="100"/>
+              </a:spcAft>
+            </a:pPr>
+            <a:r>
+              <a:rPr sz="1050" b="0">
+                <a:solidFill>
+                  <a:srgbClr val="1B222E"/>
+                </a:solidFill>
+                <a:latin typeface="微软雅黑"/>
+                <a:ea typeface="微软雅黑"/>
+              </a:rPr>
+              <a:t>· 动态 K 在图模式下端到端不劣于同预算的固定 K</a:t>
+            </a:r>
+          </a:p>
+        </p:txBody>
+      </p:sp>
+      <p:sp>
+        <p:nvSpPr>
+          <p:cNvPr id="7" name="Rounded Rectangle 6"/>
+          <p:cNvSpPr/>
+          <p:nvPr/>
+        </p:nvSpPr>
+        <p:spPr>
+          <a:xfrm>
+            <a:off x="292608" y="1700784"/>
+            <a:ext cx="2304288" cy="310896"/>
+          </a:xfrm>
+          <a:prstGeom prst="roundRect">
+            <a:avLst/>
+          </a:prstGeom>
+          <a:solidFill>
+            <a:srgbClr val="1F3050"/>
+          </a:solidFill>
+          <a:ln>
+            <a:noFill/>
+          </a:ln>
+          <a:effectLst/>
+        </p:spPr>
+        <p:style>
+          <a:lnRef idx="1">
+            <a:schemeClr val="accent1"/>
+          </a:lnRef>
+          <a:fillRef idx="3">
+            <a:schemeClr val="accent1"/>
+          </a:fillRef>
+          <a:effectRef idx="2">
+            <a:schemeClr val="accent1"/>
+          </a:effectRef>
+          <a:fontRef idx="minor">
+            <a:schemeClr val="lt1"/>
+          </a:fontRef>
+        </p:style>
+        <p:txBody>
+          <a:bodyPr rtlCol="0" anchor="ctr" wrap="square" lIns="45720" rIns="45720" tIns="18288" bIns="18288"/>
+          <a:lstStyle/>
+          <a:p>
+            <a:pPr algn="ctr">
+              <a:spcBef>
+                <a:spcPts val="0"/>
+              </a:spcBef>
+              <a:spcAft>
+                <a:spcPts val="0"/>
+              </a:spcAft>
+            </a:pPr>
+            <a:r>
+              <a:rPr sz="1150" b="0">
+                <a:solidFill>
+                  <a:srgbClr val="FFFFFF"/>
+                </a:solidFill>
+                <a:latin typeface="微软雅黑"/>
+                <a:ea typeface="微软雅黑"/>
+              </a:rPr>
+              <a:t>自适应验证运行闭环</a:t>
+            </a:r>
+          </a:p>
+        </p:txBody>
+      </p:sp>
+      <p:sp>
+        <p:nvSpPr>
+          <p:cNvPr id="8" name="Rectangle 7"/>
+          <p:cNvSpPr/>
+          <p:nvPr/>
+        </p:nvSpPr>
+        <p:spPr>
+          <a:xfrm>
+            <a:off x="292608" y="2084831"/>
+            <a:ext cx="2304288" cy="310896"/>
+          </a:xfrm>
+          <a:prstGeom prst="rect">
+            <a:avLst/>
+          </a:prstGeom>
+          <a:solidFill>
+            <a:srgbClr val="E9EEF5"/>
+          </a:solidFill>
+          <a:ln>
+            <a:noFill/>
+          </a:ln>
+          <a:effectLst/>
+        </p:spPr>
+        <p:style>
+          <a:lnRef idx="1">
+            <a:schemeClr val="accent1"/>
+          </a:lnRef>
+          <a:fillRef idx="3">
+            <a:schemeClr val="accent1"/>
+          </a:fillRef>
+          <a:effectRef idx="2">
+            <a:schemeClr val="accent1"/>
+          </a:effectRef>
+          <a:fontRef idx="minor">
+            <a:schemeClr val="lt1"/>
+          </a:fontRef>
+        </p:style>
+        <p:txBody>
+          <a:bodyPr rtlCol="0" anchor="ctr" wrap="square" lIns="45720" rIns="45720" tIns="18288" bIns="18288"/>
+          <a:lstStyle/>
+          <a:p>
+            <a:pPr algn="ctr">
+              <a:spcBef>
+                <a:spcPts val="0"/>
+              </a:spcBef>
+              <a:spcAft>
+                <a:spcPts val="0"/>
+              </a:spcAft>
+            </a:pPr>
+            <a:r>
+              <a:rPr sz="850" b="0">
+                <a:solidFill>
+                  <a:srgbClr val="1B222E"/>
+                </a:solidFill>
+                <a:latin typeface="微软雅黑"/>
+                <a:ea typeface="微软雅黑"/>
+              </a:rPr>
+              <a:t>输入:草稿 block + 逐位 confidence</a:t>
+            </a:r>
+          </a:p>
+        </p:txBody>
+      </p:sp>
+      <p:sp>
+        <p:nvSpPr>
+          <p:cNvPr id="9" name="Rectangle 8"/>
+          <p:cNvSpPr/>
+          <p:nvPr/>
+        </p:nvSpPr>
+        <p:spPr>
+          <a:xfrm>
+            <a:off x="292608" y="2487168"/>
+            <a:ext cx="2304288" cy="1572768"/>
+          </a:xfrm>
+          <a:prstGeom prst="rect">
+            <a:avLst/>
+          </a:prstGeom>
+          <a:noFill/>
+          <a:ln w="15875">
+            <a:solidFill>
+              <a:srgbClr val="1F5FA8"/>
+            </a:solidFill>
+          </a:ln>
+          <a:effectLst/>
+        </p:spPr>
+        <p:style>
+          <a:lnRef idx="1">
+            <a:schemeClr val="accent1"/>
+          </a:lnRef>
+          <a:fillRef idx="3">
+            <a:schemeClr val="accent1"/>
+          </a:fillRef>
+          <a:effectRef idx="2">
+            <a:schemeClr val="accent1"/>
+          </a:effectRef>
+          <a:fontRef idx="minor">
+            <a:schemeClr val="lt1"/>
+          </a:fontRef>
+        </p:style>
+        <p:txBody>
+          <a:bodyPr rtlCol="0" anchor="ctr"/>
+          <a:lstStyle/>
+          <a:p>
+            <a:pPr algn="ctr"/>
+          </a:p>
+        </p:txBody>
+      </p:sp>
+      <p:sp>
+        <p:nvSpPr>
+          <p:cNvPr id="10" name="Rectangle 9"/>
+          <p:cNvSpPr/>
+          <p:nvPr/>
+        </p:nvSpPr>
+        <p:spPr>
+          <a:xfrm>
+            <a:off x="347472" y="2542032"/>
+            <a:ext cx="2194560" cy="256032"/>
+          </a:xfrm>
+          <a:prstGeom prst="rect">
+            <a:avLst/>
+          </a:prstGeom>
+          <a:noFill/>
+          <a:ln>
+            <a:noFill/>
+          </a:ln>
+          <a:effectLst/>
+        </p:spPr>
+        <p:style>
+          <a:lnRef idx="1">
+            <a:schemeClr val="accent1"/>
+          </a:lnRef>
+          <a:fillRef idx="3">
+            <a:schemeClr val="accent1"/>
+          </a:fillRef>
+          <a:effectRef idx="2">
+            <a:schemeClr val="accent1"/>
+          </a:effectRef>
+          <a:fontRef idx="minor">
+            <a:schemeClr val="lt1"/>
+          </a:fontRef>
+        </p:style>
+        <p:txBody>
+          <a:bodyPr rtlCol="0" anchor="ctr" wrap="square" lIns="45720" rIns="45720" tIns="18288" bIns="18288"/>
+          <a:lstStyle/>
+          <a:p>
+            <a:pPr algn="l">
+              <a:spcBef>
+                <a:spcPts val="0"/>
+              </a:spcBef>
+              <a:spcAft>
+                <a:spcPts val="0"/>
+              </a:spcAft>
+            </a:pPr>
+            <a:r>
+              <a:rPr sz="1000" b="1">
+                <a:solidFill>
+                  <a:srgbClr val="1F5FA8"/>
+                </a:solidFill>
+                <a:latin typeface="微软雅黑"/>
+                <a:ea typeface="微软雅黑"/>
+              </a:rPr>
+              <a:t>① 置信度调度闭环</a:t>
+            </a:r>
+          </a:p>
+        </p:txBody>
+      </p:sp>
+      <p:sp>
+        <p:nvSpPr>
+          <p:cNvPr id="11" name="Rectangle 10"/>
+          <p:cNvSpPr/>
+          <p:nvPr/>
+        </p:nvSpPr>
+        <p:spPr>
+          <a:xfrm>
+            <a:off x="420624" y="2834640"/>
+            <a:ext cx="2048256" cy="292608"/>
+          </a:xfrm>
+          <a:prstGeom prst="rect">
+            <a:avLst/>
+          </a:prstGeom>
+          <a:solidFill>
+            <a:srgbClr val="FFFFFF"/>
+          </a:solidFill>
+          <a:ln w="9525">
+            <a:solidFill>
+              <a:srgbClr val="1F5FA8"/>
+            </a:solidFill>
+          </a:ln>
+          <a:effectLst/>
+        </p:spPr>
+        <p:style>
+          <a:lnRef idx="1">
+            <a:schemeClr val="accent1"/>
+          </a:lnRef>
+          <a:fillRef idx="3">
+            <a:schemeClr val="accent1"/>
+          </a:fillRef>
+          <a:effectRef idx="2">
+            <a:schemeClr val="accent1"/>
+          </a:effectRef>
+          <a:fontRef idx="minor">
+            <a:schemeClr val="lt1"/>
+          </a:fontRef>
+        </p:style>
+        <p:txBody>
+          <a:bodyPr rtlCol="0" anchor="ctr" wrap="square" lIns="45720" rIns="45720" tIns="18288" bIns="18288"/>
+          <a:lstStyle/>
+          <a:p>
+            <a:pPr algn="ctr">
+              <a:spcBef>
+                <a:spcPts val="0"/>
+              </a:spcBef>
+              <a:spcAft>
+                <a:spcPts val="0"/>
+              </a:spcAft>
+            </a:pPr>
+            <a:r>
+              <a:rPr sz="900" b="0">
+                <a:solidFill>
+                  <a:srgbClr val="1B222E"/>
+                </a:solidFill>
+                <a:latin typeface="微软雅黑"/>
+                <a:ea typeface="微软雅黑"/>
+              </a:rPr>
+              <a:t>生存概率打分</a:t>
+            </a:r>
+          </a:p>
+        </p:txBody>
+      </p:sp>
+      <p:sp>
+        <p:nvSpPr>
+          <p:cNvPr id="12" name="Down Arrow 11"/>
+          <p:cNvSpPr/>
+          <p:nvPr/>
+        </p:nvSpPr>
+        <p:spPr>
+          <a:xfrm>
+            <a:off x="1399032" y="3136392"/>
+            <a:ext cx="91440" cy="73152"/>
+          </a:xfrm>
+          <a:prstGeom prst="downArrow">
+            <a:avLst/>
+          </a:prstGeom>
+          <a:solidFill>
+            <a:srgbClr val="1F5FA8"/>
+          </a:solidFill>
+          <a:ln>
+            <a:noFill/>
+          </a:ln>
+          <a:effectLst/>
+        </p:spPr>
+        <p:style>
+          <a:lnRef idx="1">
+            <a:schemeClr val="accent1"/>
+          </a:lnRef>
+          <a:fillRef idx="3">
+            <a:schemeClr val="accent1"/>
+          </a:fillRef>
+          <a:effectRef idx="2">
+            <a:schemeClr val="accent1"/>
+          </a:effectRef>
+          <a:fontRef idx="minor">
+            <a:schemeClr val="lt1"/>
+          </a:fontRef>
+        </p:style>
+        <p:txBody>
+          <a:bodyPr rtlCol="0" anchor="ctr"/>
+          <a:lstStyle/>
+          <a:p>
+            <a:pPr algn="ctr"/>
+          </a:p>
+        </p:txBody>
+      </p:sp>
+      <p:sp>
+        <p:nvSpPr>
+          <p:cNvPr id="13" name="Rectangle 12"/>
+          <p:cNvSpPr/>
+          <p:nvPr/>
+        </p:nvSpPr>
+        <p:spPr>
+          <a:xfrm>
+            <a:off x="420624" y="3218688"/>
+            <a:ext cx="2048256" cy="292608"/>
+          </a:xfrm>
+          <a:prstGeom prst="rect">
+            <a:avLst/>
+          </a:prstGeom>
+          <a:solidFill>
+            <a:srgbClr val="FFFFFF"/>
+          </a:solidFill>
+          <a:ln w="9525">
+            <a:solidFill>
+              <a:srgbClr val="1F5FA8"/>
+            </a:solidFill>
+          </a:ln>
+          <a:effectLst/>
+        </p:spPr>
+        <p:style>
+          <a:lnRef idx="1">
+            <a:schemeClr val="accent1"/>
+          </a:lnRef>
+          <a:fillRef idx="3">
+            <a:schemeClr val="accent1"/>
+          </a:fillRef>
+          <a:effectRef idx="2">
+            <a:schemeClr val="accent1"/>
+          </a:effectRef>
+          <a:fontRef idx="minor">
+            <a:schemeClr val="lt1"/>
+          </a:fontRef>
+        </p:style>
+        <p:txBody>
+          <a:bodyPr rtlCol="0" anchor="ctr" wrap="square" lIns="45720" rIns="45720" tIns="18288" bIns="18288"/>
+          <a:lstStyle/>
+          <a:p>
+            <a:pPr algn="ctr">
+              <a:spcBef>
+                <a:spcPts val="0"/>
+              </a:spcBef>
+              <a:spcAft>
+                <a:spcPts val="0"/>
+              </a:spcAft>
+            </a:pPr>
+            <a:r>
+              <a:rPr sz="900" b="0">
+                <a:solidFill>
+                  <a:srgbClr val="1B222E"/>
+                </a:solidFill>
+                <a:latin typeface="微软雅黑"/>
+                <a:ea typeface="微软雅黑"/>
+              </a:rPr>
+              <a:t>全局预算择优</a:t>
+            </a:r>
+          </a:p>
+        </p:txBody>
+      </p:sp>
+      <p:sp>
+        <p:nvSpPr>
+          <p:cNvPr id="14" name="Down Arrow 13"/>
+          <p:cNvSpPr/>
+          <p:nvPr/>
+        </p:nvSpPr>
+        <p:spPr>
+          <a:xfrm>
+            <a:off x="1399032" y="3520440"/>
+            <a:ext cx="91440" cy="73152"/>
+          </a:xfrm>
+          <a:prstGeom prst="downArrow">
+            <a:avLst/>
+          </a:prstGeom>
+          <a:solidFill>
+            <a:srgbClr val="1F5FA8"/>
+          </a:solidFill>
+          <a:ln>
+            <a:noFill/>
+          </a:ln>
+          <a:effectLst/>
+        </p:spPr>
+        <p:style>
+          <a:lnRef idx="1">
+            <a:schemeClr val="accent1"/>
+          </a:lnRef>
+          <a:fillRef idx="3">
+            <a:schemeClr val="accent1"/>
+          </a:fillRef>
+          <a:effectRef idx="2">
+            <a:schemeClr val="accent1"/>
+          </a:effectRef>
+          <a:fontRef idx="minor">
+            <a:schemeClr val="lt1"/>
+          </a:fontRef>
+        </p:style>
+        <p:txBody>
+          <a:bodyPr rtlCol="0" anchor="ctr"/>
+          <a:lstStyle/>
+          <a:p>
+            <a:pPr algn="ctr"/>
+          </a:p>
+        </p:txBody>
+      </p:sp>
+      <p:sp>
+        <p:nvSpPr>
+          <p:cNvPr id="15" name="Rectangle 14"/>
+          <p:cNvSpPr/>
+          <p:nvPr/>
+        </p:nvSpPr>
+        <p:spPr>
+          <a:xfrm>
+            <a:off x="420624" y="3602736"/>
+            <a:ext cx="2048256" cy="292608"/>
+          </a:xfrm>
+          <a:prstGeom prst="rect">
+            <a:avLst/>
+          </a:prstGeom>
+          <a:solidFill>
+            <a:srgbClr val="FFFFFF"/>
+          </a:solidFill>
+          <a:ln w="9525">
+            <a:solidFill>
+              <a:srgbClr val="1F5FA8"/>
+            </a:solidFill>
+          </a:ln>
+          <a:effectLst/>
+        </p:spPr>
+        <p:style>
+          <a:lnRef idx="1">
+            <a:schemeClr val="accent1"/>
+          </a:lnRef>
+          <a:fillRef idx="3">
+            <a:schemeClr val="accent1"/>
+          </a:fillRef>
+          <a:effectRef idx="2">
+            <a:schemeClr val="accent1"/>
+          </a:effectRef>
+          <a:fontRef idx="minor">
+            <a:schemeClr val="lt1"/>
+          </a:fontRef>
+        </p:style>
+        <p:txBody>
+          <a:bodyPr rtlCol="0" anchor="ctr" wrap="square" lIns="45720" rIns="45720" tIns="18288" bIns="18288"/>
+          <a:lstStyle/>
+          <a:p>
+            <a:pPr algn="ctr">
+              <a:spcBef>
+                <a:spcPts val="0"/>
+              </a:spcBef>
+              <a:spcAft>
+                <a:spcPts val="0"/>
+              </a:spcAft>
+            </a:pPr>
+            <a:r>
+              <a:rPr sz="900" b="0">
+                <a:solidFill>
+                  <a:srgbClr val="1B222E"/>
+                </a:solidFill>
+                <a:latin typeface="微软雅黑"/>
+                <a:ea typeface="微软雅黑"/>
+              </a:rPr>
+              <a:t>每请求 K_i</a:t>
+            </a:r>
+          </a:p>
+        </p:txBody>
+      </p:sp>
+      <p:sp>
+        <p:nvSpPr>
+          <p:cNvPr id="16" name="Down Arrow 15"/>
+          <p:cNvSpPr/>
+          <p:nvPr/>
+        </p:nvSpPr>
+        <p:spPr>
+          <a:xfrm>
+            <a:off x="1399032" y="4087368"/>
+            <a:ext cx="91440" cy="91440"/>
+          </a:xfrm>
+          <a:prstGeom prst="downArrow">
+            <a:avLst/>
+          </a:prstGeom>
+          <a:solidFill>
+            <a:srgbClr val="1B222E"/>
+          </a:solidFill>
+          <a:ln>
+            <a:noFill/>
+          </a:ln>
+          <a:effectLst/>
+        </p:spPr>
+        <p:style>
+          <a:lnRef idx="1">
+            <a:schemeClr val="accent1"/>
+          </a:lnRef>
+          <a:fillRef idx="3">
+            <a:schemeClr val="accent1"/>
+          </a:fillRef>
+          <a:effectRef idx="2">
+            <a:schemeClr val="accent1"/>
+          </a:effectRef>
+          <a:fontRef idx="minor">
+            <a:schemeClr val="lt1"/>
+          </a:fontRef>
+        </p:style>
+        <p:txBody>
+          <a:bodyPr rtlCol="0" anchor="ctr"/>
+          <a:lstStyle/>
+          <a:p>
+            <a:pPr algn="ctr"/>
+          </a:p>
+        </p:txBody>
+      </p:sp>
+      <p:sp>
+        <p:nvSpPr>
+          <p:cNvPr id="17" name="Rectangle 16"/>
+          <p:cNvSpPr/>
+          <p:nvPr/>
+        </p:nvSpPr>
+        <p:spPr>
+          <a:xfrm>
+            <a:off x="292608" y="4224528"/>
+            <a:ext cx="2304288" cy="1572768"/>
+          </a:xfrm>
+          <a:prstGeom prst="rect">
+            <a:avLst/>
+          </a:prstGeom>
+          <a:noFill/>
+          <a:ln w="15875">
+            <a:solidFill>
+              <a:srgbClr val="D3620B"/>
+            </a:solidFill>
+          </a:ln>
+          <a:effectLst/>
+        </p:spPr>
+        <p:style>
+          <a:lnRef idx="1">
+            <a:schemeClr val="accent1"/>
+          </a:lnRef>
+          <a:fillRef idx="3">
+            <a:schemeClr val="accent1"/>
+          </a:fillRef>
+          <a:effectRef idx="2">
+            <a:schemeClr val="accent1"/>
+          </a:effectRef>
+          <a:fontRef idx="minor">
+            <a:schemeClr val="lt1"/>
+          </a:fontRef>
+        </p:style>
+        <p:txBody>
+          <a:bodyPr rtlCol="0" anchor="ctr"/>
+          <a:lstStyle/>
+          <a:p>
+            <a:pPr algn="ctr"/>
+          </a:p>
+        </p:txBody>
+      </p:sp>
+      <p:sp>
+        <p:nvSpPr>
+          <p:cNvPr id="18" name="Rectangle 17"/>
+          <p:cNvSpPr/>
+          <p:nvPr/>
+        </p:nvSpPr>
+        <p:spPr>
+          <a:xfrm>
+            <a:off x="347472" y="4279392"/>
+            <a:ext cx="2194560" cy="256032"/>
+          </a:xfrm>
+          <a:prstGeom prst="rect">
+            <a:avLst/>
+          </a:prstGeom>
+          <a:noFill/>
+          <a:ln>
+            <a:noFill/>
+          </a:ln>
+          <a:effectLst/>
+        </p:spPr>
+        <p:style>
+          <a:lnRef idx="1">
+            <a:schemeClr val="accent1"/>
+          </a:lnRef>
+          <a:fillRef idx="3">
+            <a:schemeClr val="accent1"/>
+          </a:fillRef>
+          <a:effectRef idx="2">
+            <a:schemeClr val="accent1"/>
+          </a:effectRef>
+          <a:fontRef idx="minor">
+            <a:schemeClr val="lt1"/>
+          </a:fontRef>
+        </p:style>
+        <p:txBody>
+          <a:bodyPr rtlCol="0" anchor="ctr" wrap="square" lIns="45720" rIns="45720" tIns="18288" bIns="18288"/>
+          <a:lstStyle/>
+          <a:p>
+            <a:pPr algn="l">
+              <a:spcBef>
+                <a:spcPts val="0"/>
+              </a:spcBef>
+              <a:spcAft>
+                <a:spcPts val="0"/>
+              </a:spcAft>
+            </a:pPr>
+            <a:r>
+              <a:rPr sz="1000" b="1">
+                <a:solidFill>
+                  <a:srgbClr val="D3620B"/>
+                </a:solidFill>
+                <a:latin typeface="微软雅黑"/>
+                <a:ea typeface="微软雅黑"/>
+              </a:rPr>
+              <a:t>② 变长图执行闭环</a:t>
+            </a:r>
+          </a:p>
+        </p:txBody>
+      </p:sp>
+      <p:sp>
+        <p:nvSpPr>
+          <p:cNvPr id="19" name="Rectangle 18"/>
+          <p:cNvSpPr/>
+          <p:nvPr/>
+        </p:nvSpPr>
+        <p:spPr>
+          <a:xfrm>
+            <a:off x="420624" y="4572000"/>
+            <a:ext cx="2048256" cy="292608"/>
+          </a:xfrm>
+          <a:prstGeom prst="rect">
+            <a:avLst/>
+          </a:prstGeom>
+          <a:solidFill>
+            <a:srgbClr val="FFFFFF"/>
+          </a:solidFill>
+          <a:ln w="9525">
+            <a:solidFill>
+              <a:srgbClr val="D3620B"/>
+            </a:solidFill>
+          </a:ln>
+          <a:effectLst/>
+        </p:spPr>
+        <p:style>
+          <a:lnRef idx="1">
+            <a:schemeClr val="accent1"/>
+          </a:lnRef>
+          <a:fillRef idx="3">
+            <a:schemeClr val="accent1"/>
+          </a:fillRef>
+          <a:effectRef idx="2">
+            <a:schemeClr val="accent1"/>
+          </a:effectRef>
+          <a:fontRef idx="minor">
+            <a:schemeClr val="lt1"/>
+          </a:fontRef>
+        </p:style>
+        <p:txBody>
+          <a:bodyPr rtlCol="0" anchor="ctr" wrap="square" lIns="45720" rIns="45720" tIns="18288" bIns="18288"/>
+          <a:lstStyle/>
+          <a:p>
+            <a:pPr algn="ctr">
+              <a:spcBef>
+                <a:spcPts val="0"/>
+              </a:spcBef>
+              <a:spcAft>
+                <a:spcPts val="0"/>
+              </a:spcAft>
+            </a:pPr>
+            <a:r>
+              <a:rPr sz="900" b="0">
+                <a:solidFill>
+                  <a:srgbClr val="1B222E"/>
+                </a:solidFill>
+                <a:latin typeface="微软雅黑"/>
+                <a:ea typeface="微软雅黑"/>
+              </a:rPr>
+              <a:t>变长 decode 图捕获</a:t>
+            </a:r>
+          </a:p>
+        </p:txBody>
+      </p:sp>
+      <p:sp>
+        <p:nvSpPr>
+          <p:cNvPr id="20" name="Down Arrow 19"/>
+          <p:cNvSpPr/>
+          <p:nvPr/>
+        </p:nvSpPr>
+        <p:spPr>
+          <a:xfrm>
+            <a:off x="1399032" y="4873752"/>
+            <a:ext cx="91440" cy="73152"/>
+          </a:xfrm>
+          <a:prstGeom prst="downArrow">
+            <a:avLst/>
+          </a:prstGeom>
+          <a:solidFill>
+            <a:srgbClr val="D3620B"/>
+          </a:solidFill>
+          <a:ln>
+            <a:noFill/>
+          </a:ln>
+          <a:effectLst/>
+        </p:spPr>
+        <p:style>
+          <a:lnRef idx="1">
+            <a:schemeClr val="accent1"/>
+          </a:lnRef>
+          <a:fillRef idx="3">
+            <a:schemeClr val="accent1"/>
+          </a:fillRef>
+          <a:effectRef idx="2">
+            <a:schemeClr val="accent1"/>
+          </a:effectRef>
+          <a:fontRef idx="minor">
+            <a:schemeClr val="lt1"/>
+          </a:fontRef>
+        </p:style>
+        <p:txBody>
+          <a:bodyPr rtlCol="0" anchor="ctr"/>
+          <a:lstStyle/>
+          <a:p>
+            <a:pPr algn="ctr"/>
+          </a:p>
+        </p:txBody>
+      </p:sp>
+      <p:sp>
+        <p:nvSpPr>
+          <p:cNvPr id="21" name="Rectangle 20"/>
+          <p:cNvSpPr/>
+          <p:nvPr/>
+        </p:nvSpPr>
+        <p:spPr>
+          <a:xfrm>
+            <a:off x="420624" y="4956048"/>
+            <a:ext cx="2048256" cy="292608"/>
+          </a:xfrm>
+          <a:prstGeom prst="rect">
+            <a:avLst/>
+          </a:prstGeom>
+          <a:solidFill>
+            <a:srgbClr val="FFFFFF"/>
+          </a:solidFill>
+          <a:ln w="9525">
+            <a:solidFill>
+              <a:srgbClr val="D3620B"/>
+            </a:solidFill>
+          </a:ln>
+          <a:effectLst/>
+        </p:spPr>
+        <p:style>
+          <a:lnRef idx="1">
+            <a:schemeClr val="accent1"/>
+          </a:lnRef>
+          <a:fillRef idx="3">
+            <a:schemeClr val="accent1"/>
+          </a:fillRef>
+          <a:effectRef idx="2">
+            <a:schemeClr val="accent1"/>
+          </a:effectRef>
+          <a:fontRef idx="minor">
+            <a:schemeClr val="lt1"/>
+          </a:fontRef>
+        </p:style>
+        <p:txBody>
+          <a:bodyPr rtlCol="0" anchor="ctr" wrap="square" lIns="45720" rIns="45720" tIns="18288" bIns="18288"/>
+          <a:lstStyle/>
+          <a:p>
+            <a:pPr algn="ctr">
+              <a:spcBef>
+                <a:spcPts val="0"/>
+              </a:spcBef>
+              <a:spcAft>
+                <a:spcPts val="0"/>
+              </a:spcAft>
+            </a:pPr>
+            <a:r>
+              <a:rPr sz="900" b="0">
+                <a:solidFill>
+                  <a:srgbClr val="1B222E"/>
+                </a:solidFill>
+                <a:latin typeface="微软雅黑"/>
+                <a:ea typeface="微软雅黑"/>
+              </a:rPr>
+              <a:t>真机成本曲线标定</a:t>
+            </a:r>
+          </a:p>
+        </p:txBody>
+      </p:sp>
+      <p:sp>
+        <p:nvSpPr>
+          <p:cNvPr id="22" name="Down Arrow 21"/>
+          <p:cNvSpPr/>
+          <p:nvPr/>
+        </p:nvSpPr>
+        <p:spPr>
+          <a:xfrm>
+            <a:off x="1399032" y="5257800"/>
+            <a:ext cx="91440" cy="73152"/>
+          </a:xfrm>
+          <a:prstGeom prst="downArrow">
+            <a:avLst/>
+          </a:prstGeom>
+          <a:solidFill>
+            <a:srgbClr val="D3620B"/>
+          </a:solidFill>
+          <a:ln>
+            <a:noFill/>
+          </a:ln>
+          <a:effectLst/>
+        </p:spPr>
+        <p:style>
+          <a:lnRef idx="1">
+            <a:schemeClr val="accent1"/>
+          </a:lnRef>
+          <a:fillRef idx="3">
+            <a:schemeClr val="accent1"/>
+          </a:fillRef>
+          <a:effectRef idx="2">
+            <a:schemeClr val="accent1"/>
+          </a:effectRef>
+          <a:fontRef idx="minor">
+            <a:schemeClr val="lt1"/>
+          </a:fontRef>
+        </p:style>
+        <p:txBody>
+          <a:bodyPr rtlCol="0" anchor="ctr"/>
+          <a:lstStyle/>
+          <a:p>
+            <a:pPr algn="ctr"/>
+          </a:p>
+        </p:txBody>
+      </p:sp>
+      <p:sp>
+        <p:nvSpPr>
+          <p:cNvPr id="23" name="Rectangle 22"/>
+          <p:cNvSpPr/>
+          <p:nvPr/>
+        </p:nvSpPr>
+        <p:spPr>
+          <a:xfrm>
+            <a:off x="420624" y="5340096"/>
+            <a:ext cx="2048256" cy="292608"/>
+          </a:xfrm>
+          <a:prstGeom prst="rect">
+            <a:avLst/>
+          </a:prstGeom>
+          <a:solidFill>
+            <a:srgbClr val="FFFFFF"/>
+          </a:solidFill>
+          <a:ln w="9525">
+            <a:solidFill>
+              <a:srgbClr val="D3620B"/>
+            </a:solidFill>
+          </a:ln>
+          <a:effectLst/>
+        </p:spPr>
+        <p:style>
+          <a:lnRef idx="1">
+            <a:schemeClr val="accent1"/>
+          </a:lnRef>
+          <a:fillRef idx="3">
+            <a:schemeClr val="accent1"/>
+          </a:fillRef>
+          <a:effectRef idx="2">
+            <a:schemeClr val="accent1"/>
+          </a:effectRef>
+          <a:fontRef idx="minor">
+            <a:schemeClr val="lt1"/>
+          </a:fontRef>
+        </p:style>
+        <p:txBody>
+          <a:bodyPr rtlCol="0" anchor="ctr" wrap="square" lIns="45720" rIns="45720" tIns="18288" bIns="18288"/>
+          <a:lstStyle/>
+          <a:p>
+            <a:pPr algn="ctr">
+              <a:spcBef>
+                <a:spcPts val="0"/>
+              </a:spcBef>
+              <a:spcAft>
+                <a:spcPts val="0"/>
+              </a:spcAft>
+            </a:pPr>
+            <a:r>
+              <a:rPr sz="900" b="0">
+                <a:solidFill>
+                  <a:srgbClr val="1B222E"/>
+                </a:solidFill>
+                <a:latin typeface="微软雅黑"/>
+                <a:ea typeface="微软雅黑"/>
+              </a:rPr>
+              <a:t>场景配置</a:t>
+            </a:r>
+          </a:p>
+        </p:txBody>
+      </p:sp>
+      <p:sp>
+        <p:nvSpPr>
+          <p:cNvPr id="24" name="Rectangle 23"/>
+          <p:cNvSpPr/>
+          <p:nvPr/>
+        </p:nvSpPr>
+        <p:spPr>
+          <a:xfrm>
+            <a:off x="292608" y="5907024"/>
+            <a:ext cx="2304288" cy="329184"/>
+          </a:xfrm>
+          <a:prstGeom prst="rect">
+            <a:avLst/>
+          </a:prstGeom>
+          <a:solidFill>
+            <a:srgbClr val="E9EEF5"/>
+          </a:solidFill>
+          <a:ln>
+            <a:noFill/>
+          </a:ln>
+          <a:effectLst/>
+        </p:spPr>
+        <p:style>
+          <a:lnRef idx="1">
+            <a:schemeClr val="accent1"/>
+          </a:lnRef>
+          <a:fillRef idx="3">
+            <a:schemeClr val="accent1"/>
+          </a:fillRef>
+          <a:effectRef idx="2">
+            <a:schemeClr val="accent1"/>
+          </a:effectRef>
+          <a:fontRef idx="minor">
+            <a:schemeClr val="lt1"/>
+          </a:fontRef>
+        </p:style>
+        <p:txBody>
+          <a:bodyPr rtlCol="0" anchor="ctr" wrap="square" lIns="45720" rIns="45720" tIns="18288" bIns="18288"/>
+          <a:lstStyle/>
+          <a:p>
+            <a:pPr algn="ctr">
+              <a:spcBef>
+                <a:spcPts val="0"/>
+              </a:spcBef>
+              <a:spcAft>
+                <a:spcPts val="0"/>
+              </a:spcAft>
+            </a:pPr>
+            <a:r>
+              <a:rPr sz="950" b="1">
+                <a:solidFill>
+                  <a:srgbClr val="1B222E"/>
+                </a:solidFill>
+                <a:latin typeface="微软雅黑"/>
+                <a:ea typeface="微软雅黑"/>
+              </a:rPr>
+              <a:t>可部署:动态 K 投机解码</a:t>
+            </a:r>
+          </a:p>
+        </p:txBody>
+      </p:sp>
+      <p:sp>
+        <p:nvSpPr>
+          <p:cNvPr id="25" name="TextBox 24"/>
+          <p:cNvSpPr txBox="1"/>
+          <p:nvPr/>
+        </p:nvSpPr>
+        <p:spPr>
+          <a:xfrm>
+            <a:off x="274320" y="6291072"/>
+            <a:ext cx="2395728" cy="457200"/>
+          </a:xfrm>
+          <a:prstGeom prst="rect">
+            <a:avLst/>
+          </a:prstGeom>
+          <a:noFill/>
+        </p:spPr>
+        <p:txBody>
+          <a:bodyPr wrap="square">
+            <a:spAutoFit/>
+          </a:bodyPr>
+          <a:lstStyle/>
+          <a:p>
+            <a:pPr algn="l">
+              <a:spcBef>
+                <a:spcPts val="0"/>
+              </a:spcBef>
+              <a:spcAft>
+                <a:spcPts val="0"/>
+              </a:spcAft>
+            </a:pPr>
+            <a:r>
+              <a:rPr sz="800" b="0">
+                <a:solidFill>
+                  <a:srgbClr val="C00000"/>
+                </a:solidFill>
+                <a:latin typeface="微软雅黑"/>
+                <a:ea typeface="微软雅黑"/>
+              </a:rPr>
+              <a:t>信号不可用 → 回草稿侧重拟合置信度头</a:t>
+            </a:r>
+          </a:p>
+        </p:txBody>
+      </p:sp>
+      <p:sp>
+        <p:nvSpPr>
+          <p:cNvPr id="26" name="Rectangle 25"/>
+          <p:cNvSpPr/>
+          <p:nvPr/>
+        </p:nvSpPr>
+        <p:spPr>
+          <a:xfrm>
+            <a:off x="2724912" y="1700784"/>
+            <a:ext cx="6784848" cy="2359152"/>
+          </a:xfrm>
+          <a:prstGeom prst="rect">
+            <a:avLst/>
+          </a:prstGeom>
+          <a:noFill/>
+          <a:ln w="19050">
+            <a:solidFill>
+              <a:srgbClr val="1F5FA8"/>
+            </a:solidFill>
+          </a:ln>
+          <a:effectLst/>
+        </p:spPr>
+        <p:style>
+          <a:lnRef idx="1">
+            <a:schemeClr val="accent1"/>
+          </a:lnRef>
+          <a:fillRef idx="3">
+            <a:schemeClr val="accent1"/>
+          </a:fillRef>
+          <a:effectRef idx="2">
+            <a:schemeClr val="accent1"/>
+          </a:effectRef>
+          <a:fontRef idx="minor">
+            <a:schemeClr val="lt1"/>
+          </a:fontRef>
+        </p:style>
+        <p:txBody>
+          <a:bodyPr rtlCol="0" anchor="ctr"/>
+          <a:lstStyle/>
+          <a:p>
+            <a:pPr algn="ctr"/>
+          </a:p>
+        </p:txBody>
+      </p:sp>
+      <p:sp>
+        <p:nvSpPr>
+          <p:cNvPr id="27" name="TextBox 26"/>
+          <p:cNvSpPr txBox="1"/>
+          <p:nvPr/>
+        </p:nvSpPr>
+        <p:spPr>
+          <a:xfrm>
+            <a:off x="2834640" y="1773936"/>
+            <a:ext cx="3566160" cy="310896"/>
+          </a:xfrm>
+          <a:prstGeom prst="rect">
+            <a:avLst/>
+          </a:prstGeom>
+          <a:noFill/>
+        </p:spPr>
+        <p:txBody>
+          <a:bodyPr wrap="square">
+            <a:spAutoFit/>
+          </a:bodyPr>
+          <a:lstStyle/>
+          <a:p>
+            <a:pPr algn="l">
+              <a:spcBef>
+                <a:spcPts val="0"/>
+              </a:spcBef>
+              <a:spcAft>
+                <a:spcPts val="0"/>
+              </a:spcAft>
+            </a:pPr>
+            <a:r>
+              <a:rPr sz="1300" b="1">
+                <a:solidFill>
+                  <a:srgbClr val="1F5FA8"/>
+                </a:solidFill>
+                <a:latin typeface="微软雅黑"/>
+                <a:ea typeface="微软雅黑"/>
+              </a:rPr>
+              <a:t>① 置信度调度(算法侧,对标 #47808)</a:t>
+            </a:r>
+          </a:p>
+        </p:txBody>
+      </p:sp>
+      <p:sp>
+        <p:nvSpPr>
+          <p:cNvPr id="28" name="TextBox 27"/>
+          <p:cNvSpPr txBox="1"/>
+          <p:nvPr/>
+        </p:nvSpPr>
+        <p:spPr>
+          <a:xfrm>
+            <a:off x="2834640" y="2139696"/>
+            <a:ext cx="3520440" cy="1737360"/>
+          </a:xfrm>
+          <a:prstGeom prst="rect">
+            <a:avLst/>
+          </a:prstGeom>
+          <a:noFill/>
+        </p:spPr>
+        <p:txBody>
+          <a:bodyPr wrap="square">
+            <a:spAutoFit/>
+          </a:bodyPr>
+          <a:lstStyle/>
+          <a:p>
+            <a:pPr algn="l">
+              <a:spcBef>
+                <a:spcPts val="0"/>
+              </a:spcBef>
+              <a:spcAft>
+                <a:spcPts val="0"/>
+              </a:spcAft>
+            </a:pPr>
+            <a:r>
+              <a:rPr sz="1000" b="1">
+                <a:solidFill>
+                  <a:srgbClr val="1B222E"/>
+                </a:solidFill>
+                <a:latin typeface="微软雅黑"/>
+                <a:ea typeface="微软雅黑"/>
+              </a:rPr>
+              <a:t>A. 生存概率打分</a:t>
+            </a:r>
+          </a:p>
+          <a:p>
+            <a:pPr algn="l">
+              <a:spcBef>
+                <a:spcPts val="200"/>
+              </a:spcBef>
+              <a:spcAft>
+                <a:spcPts val="0"/>
+              </a:spcAft>
+            </a:pPr>
+            <a:r>
+              <a:rPr sz="900" b="0">
+                <a:solidFill>
+                  <a:srgbClr val="1B222E"/>
+                </a:solidFill>
+                <a:latin typeface="微软雅黑"/>
+                <a:ea typeface="微软雅黑"/>
+              </a:rPr>
+              <a:t>每个 (请求, 位置) 的 draft slot 以该请求逐位 confidence 的累积乘积打分。</a:t>
+            </a:r>
+          </a:p>
+          <a:p>
+            <a:pPr algn="l">
+              <a:spcBef>
+                <a:spcPts val="200"/>
+              </a:spcBef>
+              <a:spcAft>
+                <a:spcPts val="0"/>
+              </a:spcAft>
+            </a:pPr>
+            <a:r>
+              <a:rPr sz="1000" b="1">
+                <a:solidFill>
+                  <a:srgbClr val="1B222E"/>
+                </a:solidFill>
+                <a:latin typeface="微软雅黑"/>
+                <a:ea typeface="微软雅黑"/>
+              </a:rPr>
+              <a:t>B. 跨请求竞争的全局预算</a:t>
+            </a:r>
+          </a:p>
+          <a:p>
+            <a:pPr algn="l">
+              <a:spcBef>
+                <a:spcPts val="200"/>
+              </a:spcBef>
+              <a:spcAft>
+                <a:spcPts val="0"/>
+              </a:spcAft>
+            </a:pPr>
+            <a:r>
+              <a:rPr sz="900" b="0">
+                <a:solidFill>
+                  <a:srgbClr val="1B222E"/>
+                </a:solidFill>
+                <a:latin typeface="微软雅黑"/>
+                <a:ea typeface="微软雅黑"/>
+              </a:rPr>
+              <a:t>所有 slot 统一排序、择优录取直至预算耗尽 —— 自信请求的第 5 位可压过犹豫请求的第 1 位。</a:t>
+            </a:r>
+          </a:p>
+          <a:p>
+            <a:pPr algn="l">
+              <a:spcBef>
+                <a:spcPts val="200"/>
+              </a:spcBef>
+              <a:spcAft>
+                <a:spcPts val="0"/>
+              </a:spcAft>
+            </a:pPr>
+            <a:r>
+              <a:rPr sz="1000" b="1">
+                <a:solidFill>
+                  <a:srgbClr val="1B222E"/>
+                </a:solidFill>
+                <a:latin typeface="微软雅黑"/>
+                <a:ea typeface="微软雅黑"/>
+              </a:rPr>
+              <a:t>C. 成本曲线标定</a:t>
+            </a:r>
+          </a:p>
+          <a:p>
+            <a:pPr algn="l">
+              <a:spcBef>
+                <a:spcPts val="200"/>
+              </a:spcBef>
+              <a:spcAft>
+                <a:spcPts val="0"/>
+              </a:spcAft>
+            </a:pPr>
+            <a:r>
+              <a:rPr sz="900" b="0">
+                <a:solidFill>
+                  <a:srgbClr val="1B222E"/>
+                </a:solidFill>
+                <a:latin typeface="微软雅黑"/>
+                <a:ea typeface="微软雅黑"/>
+              </a:rPr>
+              <a:t>启动期 dummy step 测出步开销;batch 预算用 CPU 侧陈旧值(不同步),per-request 用 GPU 实时值。</a:t>
+            </a:r>
+          </a:p>
+        </p:txBody>
+      </p:sp>
+      <p:sp>
+        <p:nvSpPr>
+          <p:cNvPr id="29" name="Rectangle 28"/>
+          <p:cNvSpPr/>
+          <p:nvPr/>
+        </p:nvSpPr>
+        <p:spPr>
+          <a:xfrm>
+            <a:off x="6492240" y="2395728"/>
+            <a:ext cx="841248" cy="786384"/>
+          </a:xfrm>
+          <a:prstGeom prst="rect">
+            <a:avLst/>
+          </a:prstGeom>
+          <a:solidFill>
+            <a:srgbClr val="FFFFFF"/>
+          </a:solidFill>
+          <a:ln w="9525">
+            <a:solidFill>
+              <a:srgbClr val="1F5FA8"/>
+            </a:solidFill>
+          </a:ln>
+          <a:effectLst/>
+        </p:spPr>
+        <p:style>
+          <a:lnRef idx="1">
+            <a:schemeClr val="accent1"/>
+          </a:lnRef>
+          <a:fillRef idx="3">
+            <a:schemeClr val="accent1"/>
+          </a:fillRef>
+          <a:effectRef idx="2">
+            <a:schemeClr val="accent1"/>
+          </a:effectRef>
+          <a:fontRef idx="minor">
+            <a:schemeClr val="lt1"/>
+          </a:fontRef>
+        </p:style>
+        <p:txBody>
+          <a:bodyPr rtlCol="0" anchor="ctr" wrap="square" lIns="45720" rIns="45720" tIns="18288" bIns="18288"/>
+          <a:lstStyle/>
+          <a:p>
+            <a:pPr algn="ctr">
+              <a:spcBef>
+                <a:spcPts val="100"/>
+              </a:spcBef>
+              <a:spcAft>
+                <a:spcPts val="100"/>
+              </a:spcAft>
+            </a:pPr>
+            <a:r>
+              <a:rPr sz="900" b="1">
+                <a:solidFill>
+                  <a:srgbClr val="1F5FA8"/>
+                </a:solidFill>
+                <a:latin typeface="微软雅黑"/>
+                <a:ea typeface="微软雅黑"/>
+              </a:rPr>
+              <a:t>draft slot</a:t>
+            </a:r>
+          </a:p>
+          <a:p>
+            <a:pPr algn="ctr">
+              <a:spcBef>
+                <a:spcPts val="100"/>
+              </a:spcBef>
+              <a:spcAft>
+                <a:spcPts val="100"/>
+              </a:spcAft>
+            </a:pPr>
+            <a:r>
+              <a:rPr sz="800" b="0">
+                <a:solidFill>
+                  <a:srgbClr val="5B6677"/>
+                </a:solidFill>
+                <a:latin typeface="微软雅黑"/>
+                <a:ea typeface="微软雅黑"/>
+              </a:rPr>
+              <a:t>逐位置信度</a:t>
+            </a:r>
+          </a:p>
+        </p:txBody>
+      </p:sp>
+      <p:sp>
+        <p:nvSpPr>
+          <p:cNvPr id="30" name="Right Arrow 29"/>
+          <p:cNvSpPr/>
+          <p:nvPr/>
+        </p:nvSpPr>
+        <p:spPr>
+          <a:xfrm>
+            <a:off x="7351775" y="2715768"/>
+            <a:ext cx="109728" cy="128016"/>
+          </a:xfrm>
+          <a:prstGeom prst="rightArrow">
+            <a:avLst/>
+          </a:prstGeom>
+          <a:solidFill>
+            <a:srgbClr val="1F5FA8"/>
+          </a:solidFill>
+          <a:ln>
+            <a:noFill/>
+          </a:ln>
+          <a:effectLst/>
+        </p:spPr>
+        <p:style>
+          <a:lnRef idx="1">
+            <a:schemeClr val="accent1"/>
+          </a:lnRef>
+          <a:fillRef idx="3">
+            <a:schemeClr val="accent1"/>
+          </a:fillRef>
+          <a:effectRef idx="2">
+            <a:schemeClr val="accent1"/>
+          </a:effectRef>
+          <a:fontRef idx="minor">
+            <a:schemeClr val="lt1"/>
+          </a:fontRef>
+        </p:style>
+        <p:txBody>
+          <a:bodyPr rtlCol="0" anchor="ctr"/>
+          <a:lstStyle/>
+          <a:p>
+            <a:pPr algn="ctr"/>
+          </a:p>
+        </p:txBody>
+      </p:sp>
+      <p:sp>
+        <p:nvSpPr>
+          <p:cNvPr id="31" name="Rectangle 30"/>
+          <p:cNvSpPr/>
+          <p:nvPr/>
+        </p:nvSpPr>
+        <p:spPr>
+          <a:xfrm>
+            <a:off x="7479792" y="2395728"/>
+            <a:ext cx="841248" cy="786384"/>
+          </a:xfrm>
+          <a:prstGeom prst="rect">
+            <a:avLst/>
+          </a:prstGeom>
+          <a:solidFill>
+            <a:srgbClr val="FFFFFF"/>
+          </a:solidFill>
+          <a:ln w="9525">
+            <a:solidFill>
+              <a:srgbClr val="1F5FA8"/>
+            </a:solidFill>
+          </a:ln>
+          <a:effectLst/>
+        </p:spPr>
+        <p:style>
+          <a:lnRef idx="1">
+            <a:schemeClr val="accent1"/>
+          </a:lnRef>
+          <a:fillRef idx="3">
+            <a:schemeClr val="accent1"/>
+          </a:fillRef>
+          <a:effectRef idx="2">
+            <a:schemeClr val="accent1"/>
+          </a:effectRef>
+          <a:fontRef idx="minor">
+            <a:schemeClr val="lt1"/>
+          </a:fontRef>
+        </p:style>
+        <p:txBody>
+          <a:bodyPr rtlCol="0" anchor="ctr" wrap="square" lIns="45720" rIns="45720" tIns="18288" bIns="18288"/>
+          <a:lstStyle/>
+          <a:p>
+            <a:pPr algn="ctr">
+              <a:spcBef>
+                <a:spcPts val="100"/>
+              </a:spcBef>
+              <a:spcAft>
+                <a:spcPts val="100"/>
+              </a:spcAft>
+            </a:pPr>
+            <a:r>
+              <a:rPr sz="900" b="1">
+                <a:solidFill>
+                  <a:srgbClr val="1F5FA8"/>
+                </a:solidFill>
+                <a:latin typeface="微软雅黑"/>
+                <a:ea typeface="微软雅黑"/>
+              </a:rPr>
+              <a:t>排序 / 打分</a:t>
+            </a:r>
+          </a:p>
+          <a:p>
+            <a:pPr algn="ctr">
+              <a:spcBef>
+                <a:spcPts val="100"/>
+              </a:spcBef>
+              <a:spcAft>
+                <a:spcPts val="100"/>
+              </a:spcAft>
+            </a:pPr>
+            <a:r>
+              <a:rPr sz="800" b="0">
+                <a:solidFill>
+                  <a:srgbClr val="5B6677"/>
+                </a:solidFill>
+                <a:latin typeface="微软雅黑"/>
+                <a:ea typeface="微软雅黑"/>
+              </a:rPr>
+              <a:t>累积乘积</a:t>
+            </a:r>
+          </a:p>
+        </p:txBody>
+      </p:sp>
+      <p:sp>
+        <p:nvSpPr>
+          <p:cNvPr id="32" name="Right Arrow 31"/>
+          <p:cNvSpPr/>
+          <p:nvPr/>
+        </p:nvSpPr>
+        <p:spPr>
+          <a:xfrm>
+            <a:off x="8339327" y="2715768"/>
+            <a:ext cx="109728" cy="128016"/>
+          </a:xfrm>
+          <a:prstGeom prst="rightArrow">
+            <a:avLst/>
+          </a:prstGeom>
+          <a:solidFill>
+            <a:srgbClr val="1F5FA8"/>
+          </a:solidFill>
+          <a:ln>
+            <a:noFill/>
+          </a:ln>
+          <a:effectLst/>
+        </p:spPr>
+        <p:style>
+          <a:lnRef idx="1">
+            <a:schemeClr val="accent1"/>
+          </a:lnRef>
+          <a:fillRef idx="3">
+            <a:schemeClr val="accent1"/>
+          </a:fillRef>
+          <a:effectRef idx="2">
+            <a:schemeClr val="accent1"/>
+          </a:effectRef>
+          <a:fontRef idx="minor">
+            <a:schemeClr val="lt1"/>
+          </a:fontRef>
+        </p:style>
+        <p:txBody>
+          <a:bodyPr rtlCol="0" anchor="ctr"/>
+          <a:lstStyle/>
+          <a:p>
+            <a:pPr algn="ctr"/>
+          </a:p>
+        </p:txBody>
+      </p:sp>
+      <p:sp>
+        <p:nvSpPr>
+          <p:cNvPr id="33" name="Rectangle 32"/>
+          <p:cNvSpPr/>
+          <p:nvPr/>
+        </p:nvSpPr>
+        <p:spPr>
+          <a:xfrm>
+            <a:off x="8467344" y="2395728"/>
+            <a:ext cx="841248" cy="786384"/>
+          </a:xfrm>
+          <a:prstGeom prst="rect">
+            <a:avLst/>
+          </a:prstGeom>
+          <a:solidFill>
+            <a:srgbClr val="FFFFFF"/>
+          </a:solidFill>
+          <a:ln w="9525">
+            <a:solidFill>
+              <a:srgbClr val="1F5FA8"/>
+            </a:solidFill>
+          </a:ln>
+          <a:effectLst/>
+        </p:spPr>
+        <p:style>
+          <a:lnRef idx="1">
+            <a:schemeClr val="accent1"/>
+          </a:lnRef>
+          <a:fillRef idx="3">
+            <a:schemeClr val="accent1"/>
+          </a:fillRef>
+          <a:effectRef idx="2">
+            <a:schemeClr val="accent1"/>
+          </a:effectRef>
+          <a:fontRef idx="minor">
+            <a:schemeClr val="lt1"/>
+          </a:fontRef>
+        </p:style>
+        <p:txBody>
+          <a:bodyPr rtlCol="0" anchor="ctr" wrap="square" lIns="45720" rIns="45720" tIns="18288" bIns="18288"/>
+          <a:lstStyle/>
+          <a:p>
+            <a:pPr algn="ctr">
+              <a:spcBef>
+                <a:spcPts val="100"/>
+              </a:spcBef>
+              <a:spcAft>
+                <a:spcPts val="100"/>
+              </a:spcAft>
+            </a:pPr>
+            <a:r>
+              <a:rPr sz="900" b="1">
+                <a:solidFill>
+                  <a:srgbClr val="1F5FA8"/>
+                </a:solidFill>
+                <a:latin typeface="微软雅黑"/>
+                <a:ea typeface="微软雅黑"/>
+              </a:rPr>
+              <a:t>录取前缀</a:t>
+            </a:r>
+          </a:p>
+          <a:p>
+            <a:pPr algn="ctr">
+              <a:spcBef>
+                <a:spcPts val="100"/>
+              </a:spcBef>
+              <a:spcAft>
+                <a:spcPts val="100"/>
+              </a:spcAft>
+            </a:pPr>
+            <a:r>
+              <a:rPr sz="800" b="0">
+                <a:solidFill>
+                  <a:srgbClr val="5B6677"/>
+                </a:solidFill>
+                <a:latin typeface="微软雅黑"/>
+                <a:ea typeface="微软雅黑"/>
+              </a:rPr>
+              <a:t>预算内择优</a:t>
+            </a:r>
+          </a:p>
+        </p:txBody>
+      </p:sp>
+      <p:sp>
+        <p:nvSpPr>
+          <p:cNvPr id="34" name="TextBox 33"/>
+          <p:cNvSpPr txBox="1"/>
+          <p:nvPr/>
+        </p:nvSpPr>
+        <p:spPr>
+          <a:xfrm>
+            <a:off x="6492240" y="3291840"/>
+            <a:ext cx="2889504" cy="457200"/>
+          </a:xfrm>
+          <a:prstGeom prst="rect">
+            <a:avLst/>
+          </a:prstGeom>
+          <a:noFill/>
+        </p:spPr>
+        <p:txBody>
+          <a:bodyPr wrap="square">
+            <a:spAutoFit/>
+          </a:bodyPr>
+          <a:lstStyle/>
+          <a:p>
+            <a:pPr algn="l">
+              <a:spcBef>
+                <a:spcPts val="0"/>
+              </a:spcBef>
+              <a:spcAft>
+                <a:spcPts val="0"/>
+              </a:spcAft>
+            </a:pPr>
+            <a:r>
+              <a:rPr sz="850" b="0">
+                <a:solidFill>
+                  <a:srgbClr val="5B6677"/>
+                </a:solidFill>
+                <a:latin typeface="微软雅黑"/>
+                <a:ea typeface="微软雅黑"/>
+              </a:rPr>
+              <a:t>机制示意:同预算下把验证 token 挪给最可能被接受的位置</a:t>
+            </a:r>
+          </a:p>
+        </p:txBody>
+      </p:sp>
+      <p:sp>
+        <p:nvSpPr>
+          <p:cNvPr id="35" name="Rectangle 34"/>
+          <p:cNvSpPr/>
+          <p:nvPr/>
+        </p:nvSpPr>
+        <p:spPr>
+          <a:xfrm>
+            <a:off x="2834640" y="3675887"/>
+            <a:ext cx="6565392" cy="274320"/>
+          </a:xfrm>
+          <a:prstGeom prst="rect">
+            <a:avLst/>
+          </a:prstGeom>
+          <a:solidFill>
+            <a:srgbClr val="E9EEF5"/>
+          </a:solidFill>
+          <a:ln>
+            <a:noFill/>
+          </a:ln>
+          <a:effectLst/>
+        </p:spPr>
+        <p:style>
+          <a:lnRef idx="1">
+            <a:schemeClr val="accent1"/>
+          </a:lnRef>
+          <a:fillRef idx="3">
+            <a:schemeClr val="accent1"/>
+          </a:fillRef>
+          <a:effectRef idx="2">
+            <a:schemeClr val="accent1"/>
+          </a:effectRef>
+          <a:fontRef idx="minor">
+            <a:schemeClr val="lt1"/>
+          </a:fontRef>
+        </p:style>
+        <p:txBody>
+          <a:bodyPr rtlCol="0" anchor="ctr" wrap="square" lIns="45720" rIns="45720" tIns="18288" bIns="18288"/>
+          <a:lstStyle/>
+          <a:p>
+            <a:pPr algn="ctr">
+              <a:spcBef>
+                <a:spcPts val="0"/>
+              </a:spcBef>
+              <a:spcAft>
+                <a:spcPts val="0"/>
+              </a:spcAft>
+            </a:pPr>
+            <a:r>
+              <a:rPr sz="950" b="1">
+                <a:solidFill>
+                  <a:srgbClr val="1F5FA8"/>
+                </a:solidFill>
+                <a:latin typeface="微软雅黑"/>
+                <a:ea typeface="微软雅黑"/>
+              </a:rPr>
+              <a:t>交付:昇腾预算调度 kernel  |  成本曲线标定脚本  |  置信度-接受率相关性报告</a:t>
+            </a:r>
+          </a:p>
+        </p:txBody>
+      </p:sp>
+      <p:sp>
+        <p:nvSpPr>
+          <p:cNvPr id="36" name="Rectangle 35"/>
+          <p:cNvSpPr/>
+          <p:nvPr/>
+        </p:nvSpPr>
+        <p:spPr>
+          <a:xfrm>
+            <a:off x="2724912" y="4206240"/>
+            <a:ext cx="6784848" cy="2487168"/>
+          </a:xfrm>
+          <a:prstGeom prst="rect">
+            <a:avLst/>
+          </a:prstGeom>
+          <a:noFill/>
+          <a:ln w="19050">
+            <a:solidFill>
+              <a:srgbClr val="D3620B"/>
+            </a:solidFill>
+          </a:ln>
+          <a:effectLst/>
+        </p:spPr>
+        <p:style>
+          <a:lnRef idx="1">
+            <a:schemeClr val="accent1"/>
+          </a:lnRef>
+          <a:fillRef idx="3">
+            <a:schemeClr val="accent1"/>
+          </a:fillRef>
+          <a:effectRef idx="2">
+            <a:schemeClr val="accent1"/>
+          </a:effectRef>
+          <a:fontRef idx="minor">
+            <a:schemeClr val="lt1"/>
+          </a:fontRef>
+        </p:style>
+        <p:txBody>
+          <a:bodyPr rtlCol="0" anchor="ctr"/>
+          <a:lstStyle/>
+          <a:p>
+            <a:pPr algn="ctr"/>
+          </a:p>
+        </p:txBody>
+      </p:sp>
+      <p:sp>
+        <p:nvSpPr>
+          <p:cNvPr id="37" name="TextBox 36"/>
+          <p:cNvSpPr txBox="1"/>
+          <p:nvPr/>
+        </p:nvSpPr>
+        <p:spPr>
+          <a:xfrm>
+            <a:off x="2834640" y="4279392"/>
+            <a:ext cx="3840480" cy="310896"/>
+          </a:xfrm>
+          <a:prstGeom prst="rect">
+            <a:avLst/>
+          </a:prstGeom>
+          <a:noFill/>
+        </p:spPr>
+        <p:txBody>
+          <a:bodyPr wrap="square">
+            <a:spAutoFit/>
+          </a:bodyPr>
+          <a:lstStyle/>
+          <a:p>
+            <a:pPr algn="l">
+              <a:spcBef>
+                <a:spcPts val="0"/>
+              </a:spcBef>
+              <a:spcAft>
+                <a:spcPts val="0"/>
+              </a:spcAft>
+            </a:pPr>
+            <a:r>
+              <a:rPr sz="1300" b="1">
+                <a:solidFill>
+                  <a:srgbClr val="D3620B"/>
+                </a:solidFill>
+                <a:latin typeface="微软雅黑"/>
+                <a:ea typeface="微软雅黑"/>
+              </a:rPr>
+              <a:t>② 变长 decode 图(工程侧,★ 主要投入)</a:t>
+            </a:r>
+          </a:p>
+        </p:txBody>
+      </p:sp>
+      <p:sp>
+        <p:nvSpPr>
+          <p:cNvPr id="38" name="Rectangle 37"/>
+          <p:cNvSpPr/>
+          <p:nvPr/>
+        </p:nvSpPr>
+        <p:spPr>
+          <a:xfrm>
+            <a:off x="2871216" y="4663440"/>
+            <a:ext cx="987552" cy="731520"/>
+          </a:xfrm>
+          <a:prstGeom prst="rect">
+            <a:avLst/>
+          </a:prstGeom>
+          <a:solidFill>
+            <a:srgbClr val="FFFFFF"/>
+          </a:solidFill>
+          <a:ln w="9525">
+            <a:solidFill>
+              <a:srgbClr val="D3620B"/>
+            </a:solidFill>
+          </a:ln>
+          <a:effectLst/>
+        </p:spPr>
+        <p:style>
+          <a:lnRef idx="1">
+            <a:schemeClr val="accent1"/>
+          </a:lnRef>
+          <a:fillRef idx="3">
+            <a:schemeClr val="accent1"/>
+          </a:fillRef>
+          <a:effectRef idx="2">
+            <a:schemeClr val="accent1"/>
+          </a:effectRef>
+          <a:fontRef idx="minor">
+            <a:schemeClr val="lt1"/>
+          </a:fontRef>
+        </p:style>
+        <p:txBody>
+          <a:bodyPr rtlCol="0" anchor="ctr" wrap="square" lIns="45720" rIns="45720" tIns="18288" bIns="18288"/>
+          <a:lstStyle/>
+          <a:p>
+            <a:pPr algn="ctr">
+              <a:spcBef>
+                <a:spcPts val="100"/>
+              </a:spcBef>
+              <a:spcAft>
+                <a:spcPts val="100"/>
+              </a:spcAft>
+            </a:pPr>
+            <a:r>
+              <a:rPr sz="900" b="1">
+                <a:solidFill>
+                  <a:srgbClr val="D3620B"/>
+                </a:solidFill>
+                <a:latin typeface="微软雅黑"/>
+                <a:ea typeface="微软雅黑"/>
+              </a:rPr>
+              <a:t>固定形状捕获</a:t>
+            </a:r>
+          </a:p>
+          <a:p>
+            <a:pPr algn="ctr">
+              <a:spcBef>
+                <a:spcPts val="100"/>
+              </a:spcBef>
+              <a:spcAft>
+                <a:spcPts val="100"/>
+              </a:spcAft>
+            </a:pPr>
+            <a:r>
+              <a:rPr sz="800" b="0">
+                <a:solidFill>
+                  <a:srgbClr val="5B6677"/>
+                </a:solidFill>
+                <a:latin typeface="微软雅黑"/>
+                <a:ea typeface="微软雅黑"/>
+              </a:rPr>
+              <a:t>现状</a:t>
+            </a:r>
+          </a:p>
+        </p:txBody>
+      </p:sp>
+      <p:sp>
+        <p:nvSpPr>
+          <p:cNvPr id="39" name="Right Arrow 38"/>
+          <p:cNvSpPr/>
+          <p:nvPr/>
+        </p:nvSpPr>
+        <p:spPr>
+          <a:xfrm>
+            <a:off x="3877056" y="4965192"/>
+            <a:ext cx="109728" cy="128016"/>
+          </a:xfrm>
+          <a:prstGeom prst="rightArrow">
+            <a:avLst/>
+          </a:prstGeom>
+          <a:solidFill>
+            <a:srgbClr val="D3620B"/>
+          </a:solidFill>
+          <a:ln>
+            <a:noFill/>
+          </a:ln>
+          <a:effectLst/>
+        </p:spPr>
+        <p:style>
+          <a:lnRef idx="1">
+            <a:schemeClr val="accent1"/>
+          </a:lnRef>
+          <a:fillRef idx="3">
+            <a:schemeClr val="accent1"/>
+          </a:fillRef>
+          <a:effectRef idx="2">
+            <a:schemeClr val="accent1"/>
+          </a:effectRef>
+          <a:fontRef idx="minor">
+            <a:schemeClr val="lt1"/>
+          </a:fontRef>
+        </p:style>
+        <p:txBody>
+          <a:bodyPr rtlCol="0" anchor="ctr"/>
+          <a:lstStyle/>
+          <a:p>
+            <a:pPr algn="ctr"/>
+          </a:p>
+        </p:txBody>
+      </p:sp>
+      <p:sp>
+        <p:nvSpPr>
+          <p:cNvPr id="40" name="Rectangle 39"/>
+          <p:cNvSpPr/>
+          <p:nvPr/>
+        </p:nvSpPr>
+        <p:spPr>
+          <a:xfrm>
+            <a:off x="4005072" y="4663440"/>
+            <a:ext cx="987552" cy="731520"/>
+          </a:xfrm>
+          <a:prstGeom prst="rect">
+            <a:avLst/>
+          </a:prstGeom>
+          <a:solidFill>
+            <a:srgbClr val="FFFFFF"/>
+          </a:solidFill>
+          <a:ln w="9525">
+            <a:solidFill>
+              <a:srgbClr val="D3620B"/>
+            </a:solidFill>
+          </a:ln>
+          <a:effectLst/>
+        </p:spPr>
+        <p:style>
+          <a:lnRef idx="1">
+            <a:schemeClr val="accent1"/>
+          </a:lnRef>
+          <a:fillRef idx="3">
+            <a:schemeClr val="accent1"/>
+          </a:fillRef>
+          <a:effectRef idx="2">
+            <a:schemeClr val="accent1"/>
+          </a:effectRef>
+          <a:fontRef idx="minor">
+            <a:schemeClr val="lt1"/>
+          </a:fontRef>
+        </p:style>
+        <p:txBody>
+          <a:bodyPr rtlCol="0" anchor="ctr" wrap="square" lIns="45720" rIns="45720" tIns="18288" bIns="18288"/>
+          <a:lstStyle/>
+          <a:p>
+            <a:pPr algn="ctr">
+              <a:spcBef>
+                <a:spcPts val="100"/>
+              </a:spcBef>
+              <a:spcAft>
+                <a:spcPts val="100"/>
+              </a:spcAft>
+            </a:pPr>
+            <a:r>
+              <a:rPr sz="900" b="1">
+                <a:solidFill>
+                  <a:srgbClr val="D3620B"/>
+                </a:solidFill>
+                <a:latin typeface="微软雅黑"/>
+                <a:ea typeface="微软雅黑"/>
+              </a:rPr>
+              <a:t>变长图</a:t>
+            </a:r>
+          </a:p>
+          <a:p>
+            <a:pPr algn="ctr">
+              <a:spcBef>
+                <a:spcPts val="100"/>
+              </a:spcBef>
+              <a:spcAft>
+                <a:spcPts val="100"/>
+              </a:spcAft>
+            </a:pPr>
+            <a:r>
+              <a:rPr sz="800" b="0">
+                <a:solidFill>
+                  <a:srgbClr val="5B6677"/>
+                </a:solidFill>
+                <a:latin typeface="微软雅黑"/>
+                <a:ea typeface="微软雅黑"/>
+              </a:rPr>
+              <a:t>按 token 网格</a:t>
+            </a:r>
+          </a:p>
+        </p:txBody>
+      </p:sp>
+      <p:sp>
+        <p:nvSpPr>
+          <p:cNvPr id="41" name="Right Arrow 40"/>
+          <p:cNvSpPr/>
+          <p:nvPr/>
+        </p:nvSpPr>
+        <p:spPr>
+          <a:xfrm>
+            <a:off x="5010912" y="4965192"/>
+            <a:ext cx="109728" cy="128016"/>
+          </a:xfrm>
+          <a:prstGeom prst="rightArrow">
+            <a:avLst/>
+          </a:prstGeom>
+          <a:solidFill>
+            <a:srgbClr val="D3620B"/>
+          </a:solidFill>
+          <a:ln>
+            <a:noFill/>
+          </a:ln>
+          <a:effectLst/>
+        </p:spPr>
+        <p:style>
+          <a:lnRef idx="1">
+            <a:schemeClr val="accent1"/>
+          </a:lnRef>
+          <a:fillRef idx="3">
+            <a:schemeClr val="accent1"/>
+          </a:fillRef>
+          <a:effectRef idx="2">
+            <a:schemeClr val="accent1"/>
+          </a:effectRef>
+          <a:fontRef idx="minor">
+            <a:schemeClr val="lt1"/>
+          </a:fontRef>
+        </p:style>
+        <p:txBody>
+          <a:bodyPr rtlCol="0" anchor="ctr"/>
+          <a:lstStyle/>
+          <a:p>
+            <a:pPr algn="ctr"/>
+          </a:p>
+        </p:txBody>
+      </p:sp>
+      <p:sp>
+        <p:nvSpPr>
+          <p:cNvPr id="42" name="Rectangle 41"/>
+          <p:cNvSpPr/>
+          <p:nvPr/>
+        </p:nvSpPr>
+        <p:spPr>
+          <a:xfrm>
+            <a:off x="5138928" y="4663440"/>
+            <a:ext cx="987552" cy="731520"/>
+          </a:xfrm>
+          <a:prstGeom prst="rect">
+            <a:avLst/>
+          </a:prstGeom>
+          <a:solidFill>
+            <a:srgbClr val="FFFFFF"/>
+          </a:solidFill>
+          <a:ln w="9525">
+            <a:solidFill>
+              <a:srgbClr val="D3620B"/>
+            </a:solidFill>
+          </a:ln>
+          <a:effectLst/>
+        </p:spPr>
+        <p:style>
+          <a:lnRef idx="1">
+            <a:schemeClr val="accent1"/>
+          </a:lnRef>
+          <a:fillRef idx="3">
+            <a:schemeClr val="accent1"/>
+          </a:fillRef>
+          <a:effectRef idx="2">
+            <a:schemeClr val="accent1"/>
+          </a:effectRef>
+          <a:fontRef idx="minor">
+            <a:schemeClr val="lt1"/>
+          </a:fontRef>
+        </p:style>
+        <p:txBody>
+          <a:bodyPr rtlCol="0" anchor="ctr" wrap="square" lIns="45720" rIns="45720" tIns="18288" bIns="18288"/>
+          <a:lstStyle/>
+          <a:p>
+            <a:pPr algn="ctr">
+              <a:spcBef>
+                <a:spcPts val="100"/>
+              </a:spcBef>
+              <a:spcAft>
+                <a:spcPts val="100"/>
+              </a:spcAft>
+            </a:pPr>
+            <a:r>
+              <a:rPr sz="900" b="1">
+                <a:solidFill>
+                  <a:srgbClr val="D3620B"/>
+                </a:solidFill>
+                <a:latin typeface="微软雅黑"/>
+                <a:ea typeface="微软雅黑"/>
+              </a:rPr>
+              <a:t>真机测量</a:t>
+            </a:r>
+          </a:p>
+          <a:p>
+            <a:pPr algn="ctr">
+              <a:spcBef>
+                <a:spcPts val="100"/>
+              </a:spcBef>
+              <a:spcAft>
+                <a:spcPts val="100"/>
+              </a:spcAft>
+            </a:pPr>
+            <a:r>
+              <a:rPr sz="800" b="0">
+                <a:solidFill>
+                  <a:srgbClr val="5B6677"/>
+                </a:solidFill>
+                <a:latin typeface="微软雅黑"/>
+                <a:ea typeface="微软雅黑"/>
+              </a:rPr>
+              <a:t>开销 / padding</a:t>
+            </a:r>
+          </a:p>
+        </p:txBody>
+      </p:sp>
+      <p:sp>
+        <p:nvSpPr>
+          <p:cNvPr id="43" name="TextBox 42"/>
+          <p:cNvSpPr txBox="1"/>
+          <p:nvPr/>
+        </p:nvSpPr>
+        <p:spPr>
+          <a:xfrm>
+            <a:off x="2871216" y="5504688"/>
+            <a:ext cx="3383280" cy="822960"/>
+          </a:xfrm>
+          <a:prstGeom prst="rect">
+            <a:avLst/>
+          </a:prstGeom>
+          <a:noFill/>
+        </p:spPr>
+        <p:txBody>
+          <a:bodyPr wrap="square">
+            <a:spAutoFit/>
+          </a:bodyPr>
+          <a:lstStyle/>
+          <a:p>
+            <a:pPr algn="l">
+              <a:spcBef>
+                <a:spcPts val="0"/>
+              </a:spcBef>
+              <a:spcAft>
+                <a:spcPts val="0"/>
+              </a:spcAft>
+            </a:pPr>
+            <a:r>
+              <a:rPr sz="900" b="1">
+                <a:solidFill>
+                  <a:srgbClr val="1B222E"/>
+                </a:solidFill>
+                <a:latin typeface="微软雅黑"/>
+                <a:ea typeface="微软雅黑"/>
+              </a:rPr>
+              <a:t>两条候选路线,阶段 2 先验证可行性再投入:</a:t>
+            </a:r>
+          </a:p>
+          <a:p>
+            <a:pPr algn="l">
+              <a:spcBef>
+                <a:spcPts val="150"/>
+              </a:spcBef>
+              <a:spcAft>
+                <a:spcPts val="0"/>
+              </a:spcAft>
+            </a:pPr>
+            <a:r>
+              <a:rPr sz="850" b="0">
+                <a:solidFill>
+                  <a:srgbClr val="1B222E"/>
+                </a:solidFill>
+                <a:latin typeface="微软雅黑"/>
+                <a:ea typeface="微软雅黑"/>
+              </a:rPr>
+              <a:t>· 对齐上游语义 —— 后端上报 ALWAYS,按 max_query_len 派发;</a:t>
+            </a:r>
+          </a:p>
+          <a:p>
+            <a:pPr algn="l">
+              <a:spcBef>
+                <a:spcPts val="150"/>
+              </a:spcBef>
+              <a:spcAft>
+                <a:spcPts val="0"/>
+              </a:spcAft>
+            </a:pPr>
+            <a:r>
+              <a:rPr sz="850" b="0">
+                <a:solidFill>
+                  <a:srgbClr val="1B222E"/>
+                </a:solidFill>
+                <a:latin typeface="微软雅黑"/>
+                <a:ea typeface="微软雅黑"/>
+              </a:rPr>
+              <a:t>· SGLang 式 packed varlen —— graph key 只按总 token 数,padding 更省。</a:t>
+            </a:r>
+          </a:p>
+        </p:txBody>
+      </p:sp>
+      <p:sp>
+        <p:nvSpPr>
+          <p:cNvPr id="44" name="TextBox 43"/>
+          <p:cNvSpPr txBox="1"/>
+          <p:nvPr/>
+        </p:nvSpPr>
+        <p:spPr>
+          <a:xfrm>
+            <a:off x="6437375" y="4626864"/>
+            <a:ext cx="2962656" cy="1737360"/>
+          </a:xfrm>
+          <a:prstGeom prst="rect">
+            <a:avLst/>
+          </a:prstGeom>
+          <a:noFill/>
+        </p:spPr>
+        <p:txBody>
+          <a:bodyPr wrap="square">
+            <a:spAutoFit/>
+          </a:bodyPr>
+          <a:lstStyle/>
+          <a:p>
+            <a:pPr algn="l">
+              <a:spcBef>
+                <a:spcPts val="0"/>
+              </a:spcBef>
+              <a:spcAft>
+                <a:spcPts val="0"/>
+              </a:spcAft>
+            </a:pPr>
+            <a:r>
+              <a:rPr sz="850" b="0">
+                <a:solidFill>
+                  <a:srgbClr val="1B222E"/>
+                </a:solidFill>
+                <a:latin typeface="微软雅黑"/>
+                <a:ea typeface="微软雅黑"/>
+              </a:rPr>
+              <a:t>· 昇腾无对应的「任意形状可入图」机制,这是本项目唯一的阻断性风险;</a:t>
+            </a:r>
+          </a:p>
+          <a:p>
+            <a:pPr algn="l">
+              <a:spcBef>
+                <a:spcPts val="300"/>
+              </a:spcBef>
+              <a:spcAft>
+                <a:spcPts val="0"/>
+              </a:spcAft>
+            </a:pPr>
+            <a:r>
+              <a:rPr sz="850" b="0">
+                <a:solidFill>
+                  <a:srgbClr val="1B222E"/>
+                </a:solidFill>
+                <a:latin typeface="微软雅黑"/>
+                <a:ea typeface="微软雅黑"/>
+              </a:rPr>
+              <a:t>· 上游为 NVIDIA 后端加了 ALWAYS 声明,昇腾需自建等价能力;</a:t>
+            </a:r>
+          </a:p>
+          <a:p>
+            <a:pPr algn="l">
+              <a:spcBef>
+                <a:spcPts val="300"/>
+              </a:spcBef>
+              <a:spcAft>
+                <a:spcPts val="0"/>
+              </a:spcAft>
+            </a:pPr>
+            <a:r>
+              <a:rPr sz="850" b="0">
+                <a:solidFill>
+                  <a:srgbClr val="C00000"/>
+                </a:solidFill>
+                <a:latin typeface="微软雅黑"/>
+                <a:ea typeface="微软雅黑"/>
+              </a:rPr>
+              <a:t>· 若不可行,保留 eager 路径成果,并把图支持作为独立议题提交上游。</a:t>
+            </a:r>
+          </a:p>
+        </p:txBody>
+      </p:sp>
+      <p:sp>
+        <p:nvSpPr>
+          <p:cNvPr id="45" name="Rectangle 44"/>
+          <p:cNvSpPr/>
+          <p:nvPr/>
+        </p:nvSpPr>
+        <p:spPr>
+          <a:xfrm>
+            <a:off x="2834640" y="6327648"/>
+            <a:ext cx="6565392" cy="274320"/>
+          </a:xfrm>
+          <a:prstGeom prst="rect">
+            <a:avLst/>
+          </a:prstGeom>
+          <a:solidFill>
+            <a:srgbClr val="FDF0E4"/>
+          </a:solidFill>
+          <a:ln>
+            <a:noFill/>
+          </a:ln>
+          <a:effectLst/>
+        </p:spPr>
+        <p:style>
+          <a:lnRef idx="1">
+            <a:schemeClr val="accent1"/>
+          </a:lnRef>
+          <a:fillRef idx="3">
+            <a:schemeClr val="accent1"/>
+          </a:fillRef>
+          <a:effectRef idx="2">
+            <a:schemeClr val="accent1"/>
+          </a:effectRef>
+          <a:fontRef idx="minor">
+            <a:schemeClr val="lt1"/>
+          </a:fontRef>
+        </p:style>
+        <p:txBody>
+          <a:bodyPr rtlCol="0" anchor="ctr" wrap="square" lIns="45720" rIns="45720" tIns="18288" bIns="18288"/>
+          <a:lstStyle/>
+          <a:p>
+            <a:pPr algn="ctr">
+              <a:spcBef>
+                <a:spcPts val="0"/>
+              </a:spcBef>
+              <a:spcAft>
+                <a:spcPts val="0"/>
+              </a:spcAft>
+            </a:pPr>
+            <a:r>
+              <a:rPr sz="950" b="1">
+                <a:solidFill>
+                  <a:srgbClr val="D3620B"/>
+                </a:solidFill>
+                <a:latin typeface="微软雅黑"/>
+                <a:ea typeface="微软雅黑"/>
+              </a:rPr>
+              <a:t>交付:变长 decode 图实现  |  Shape 配置  |  三模式(无投机 / 固定 K / 动态 K)对比实测包</a:t>
+            </a:r>
+          </a:p>
+        </p:txBody>
+      </p:sp>
+      <p:sp>
+        <p:nvSpPr>
+          <p:cNvPr id="46" name="Rectangle 45"/>
+          <p:cNvSpPr/>
+          <p:nvPr/>
+        </p:nvSpPr>
+        <p:spPr>
+          <a:xfrm>
+            <a:off x="9637776" y="1700784"/>
+            <a:ext cx="2231136" cy="310896"/>
+          </a:xfrm>
+          <a:prstGeom prst="rect">
+            <a:avLst/>
+          </a:prstGeom>
+          <a:solidFill>
+            <a:srgbClr val="C00000"/>
+          </a:solidFill>
+          <a:ln>
+            <a:noFill/>
+          </a:ln>
+          <a:effectLst/>
+        </p:spPr>
+        <p:style>
+          <a:lnRef idx="1">
+            <a:schemeClr val="accent1"/>
+          </a:lnRef>
+          <a:fillRef idx="3">
+            <a:schemeClr val="accent1"/>
+          </a:fillRef>
+          <a:effectRef idx="2">
+            <a:schemeClr val="accent1"/>
+          </a:effectRef>
+          <a:fontRef idx="minor">
+            <a:schemeClr val="lt1"/>
+          </a:fontRef>
+        </p:style>
+        <p:txBody>
+          <a:bodyPr rtlCol="0" anchor="ctr" wrap="square" lIns="45720" rIns="45720" tIns="18288" bIns="18288"/>
+          <a:lstStyle/>
+          <a:p>
+            <a:pPr algn="ctr">
+              <a:spcBef>
+                <a:spcPts val="0"/>
+              </a:spcBef>
+              <a:spcAft>
+                <a:spcPts val="0"/>
+              </a:spcAft>
+            </a:pPr>
+            <a:r>
+              <a:rPr sz="1200" b="1">
+                <a:solidFill>
+                  <a:srgbClr val="FFFFFF"/>
+                </a:solidFill>
+                <a:latin typeface="微软雅黑"/>
+                <a:ea typeface="微软雅黑"/>
+              </a:rPr>
+              <a:t>里 程 碑</a:t>
+            </a:r>
+          </a:p>
+        </p:txBody>
+      </p:sp>
+      <p:sp>
+        <p:nvSpPr>
+          <p:cNvPr id="47" name="Rectangle 46"/>
+          <p:cNvSpPr/>
+          <p:nvPr/>
+        </p:nvSpPr>
+        <p:spPr>
+          <a:xfrm>
+            <a:off x="9838944" y="2212848"/>
+            <a:ext cx="25603" cy="4160520"/>
+          </a:xfrm>
+          <a:prstGeom prst="rect">
+            <a:avLst/>
+          </a:prstGeom>
+          <a:solidFill>
+            <a:srgbClr val="C00000"/>
+          </a:solidFill>
+          <a:ln>
+            <a:noFill/>
+          </a:ln>
+          <a:effectLst/>
+        </p:spPr>
+        <p:style>
+          <a:lnRef idx="1">
+            <a:schemeClr val="accent1"/>
+          </a:lnRef>
+          <a:fillRef idx="3">
+            <a:schemeClr val="accent1"/>
+          </a:fillRef>
+          <a:effectRef idx="2">
+            <a:schemeClr val="accent1"/>
+          </a:effectRef>
+          <a:fontRef idx="minor">
+            <a:schemeClr val="lt1"/>
+          </a:fontRef>
+        </p:style>
+        <p:txBody>
+          <a:bodyPr rtlCol="0" anchor="ctr"/>
+          <a:lstStyle/>
+          <a:p>
+            <a:pPr algn="ctr"/>
+          </a:p>
+        </p:txBody>
+      </p:sp>
+      <p:sp>
+        <p:nvSpPr>
+          <p:cNvPr id="48" name="Oval 47"/>
+          <p:cNvSpPr/>
+          <p:nvPr/>
+        </p:nvSpPr>
+        <p:spPr>
+          <a:xfrm>
+            <a:off x="9720072" y="2249424"/>
+            <a:ext cx="274320" cy="274320"/>
+          </a:xfrm>
+          <a:prstGeom prst="ellipse">
+            <a:avLst/>
+          </a:prstGeom>
+          <a:solidFill>
+            <a:srgbClr val="FFFFFF"/>
+          </a:solidFill>
+          <a:ln w="15875">
+            <a:solidFill>
+              <a:srgbClr val="C00000"/>
+            </a:solidFill>
+          </a:ln>
+          <a:effectLst/>
+        </p:spPr>
+        <p:style>
+          <a:lnRef idx="1">
+            <a:schemeClr val="accent1"/>
+          </a:lnRef>
+          <a:fillRef idx="3">
+            <a:schemeClr val="accent1"/>
+          </a:fillRef>
+          <a:effectRef idx="2">
+            <a:schemeClr val="accent1"/>
+          </a:effectRef>
+          <a:fontRef idx="minor">
+            <a:schemeClr val="lt1"/>
+          </a:fontRef>
+        </p:style>
+        <p:txBody>
+          <a:bodyPr rtlCol="0" anchor="ctr" wrap="square" lIns="45720" rIns="45720" tIns="18288" bIns="18288"/>
+          <a:lstStyle/>
+          <a:p>
+            <a:pPr algn="ctr">
+              <a:spcBef>
+                <a:spcPts val="0"/>
+              </a:spcBef>
+              <a:spcAft>
+                <a:spcPts val="0"/>
+              </a:spcAft>
+            </a:pPr>
+            <a:r>
+              <a:rPr sz="1000" b="1">
+                <a:solidFill>
+                  <a:srgbClr val="C00000"/>
+                </a:solidFill>
+                <a:latin typeface="微软雅黑"/>
+                <a:ea typeface="微软雅黑"/>
+              </a:rPr>
+              <a:t>1</a:t>
+            </a:r>
+          </a:p>
+        </p:txBody>
+      </p:sp>
+      <p:sp>
+        <p:nvSpPr>
+          <p:cNvPr id="49" name="TextBox 48"/>
+          <p:cNvSpPr txBox="1"/>
+          <p:nvPr/>
+        </p:nvSpPr>
+        <p:spPr>
+          <a:xfrm>
+            <a:off x="10058400" y="2194560"/>
+            <a:ext cx="1773936" cy="1005840"/>
+          </a:xfrm>
+          <a:prstGeom prst="rect">
+            <a:avLst/>
+          </a:prstGeom>
+          <a:noFill/>
+        </p:spPr>
+        <p:txBody>
+          <a:bodyPr wrap="square">
+            <a:spAutoFit/>
+          </a:bodyPr>
+          <a:lstStyle/>
+          <a:p>
+            <a:pPr algn="l">
+              <a:spcBef>
+                <a:spcPts val="0"/>
+              </a:spcBef>
+              <a:spcAft>
+                <a:spcPts val="0"/>
+              </a:spcAft>
+            </a:pPr>
+            <a:r>
+              <a:rPr sz="1150" b="1">
+                <a:solidFill>
+                  <a:srgbClr val="C00000"/>
+                </a:solidFill>
+                <a:latin typeface="微软雅黑"/>
+                <a:ea typeface="微软雅黑"/>
+              </a:rPr>
+              <a:t>T+1 天</a:t>
+            </a:r>
+          </a:p>
+          <a:p>
+            <a:pPr algn="l">
+              <a:spcBef>
+                <a:spcPts val="100"/>
+              </a:spcBef>
+              <a:spcAft>
+                <a:spcPts val="0"/>
+              </a:spcAft>
+            </a:pPr>
+            <a:r>
+              <a:rPr sz="1000" b="1">
+                <a:solidFill>
+                  <a:srgbClr val="1B222E"/>
+                </a:solidFill>
+                <a:latin typeface="微软雅黑"/>
+                <a:ea typeface="微软雅黑"/>
+              </a:rPr>
+              <a:t>G1 · 判定</a:t>
+            </a:r>
+          </a:p>
+          <a:p>
+            <a:pPr algn="l">
+              <a:spcBef>
+                <a:spcPts val="100"/>
+              </a:spcBef>
+              <a:spcAft>
+                <a:spcPts val="0"/>
+              </a:spcAft>
+            </a:pPr>
+            <a:r>
+              <a:rPr sz="800" b="0">
+                <a:solidFill>
+                  <a:srgbClr val="5B6677"/>
+                </a:solidFill>
+                <a:latin typeface="微软雅黑"/>
+                <a:ea typeface="微软雅黑"/>
+              </a:rPr>
+              <a:t>把加速比从 c=48 补测到</a:t>
+            </a:r>
+          </a:p>
+          <a:p>
+            <a:pPr algn="l">
+              <a:spcBef>
+                <a:spcPts val="100"/>
+              </a:spcBef>
+              <a:spcAft>
+                <a:spcPts val="0"/>
+              </a:spcAft>
+            </a:pPr>
+            <a:r>
+              <a:rPr sz="800" b="0">
+                <a:solidFill>
+                  <a:srgbClr val="5B6677"/>
+                </a:solidFill>
+                <a:latin typeface="微软雅黑"/>
+                <a:ea typeface="微软雅黑"/>
+              </a:rPr>
+              <a:t>c=128 / c=256</a:t>
+            </a:r>
+          </a:p>
+          <a:p>
+            <a:pPr algn="l">
+              <a:spcBef>
+                <a:spcPts val="100"/>
+              </a:spcBef>
+              <a:spcAft>
+                <a:spcPts val="0"/>
+              </a:spcAft>
+            </a:pPr>
+            <a:r>
+              <a:rPr sz="800" b="0">
+                <a:solidFill>
+                  <a:srgbClr val="5B6677"/>
+                </a:solidFill>
+                <a:latin typeface="微软雅黑"/>
+                <a:ea typeface="微软雅黑"/>
+              </a:rPr>
+              <a:t>看固定 K 是否收益衰减</a:t>
+            </a:r>
+          </a:p>
+          <a:p>
+            <a:pPr algn="l">
+              <a:spcBef>
+                <a:spcPts val="100"/>
+              </a:spcBef>
+              <a:spcAft>
+                <a:spcPts val="0"/>
+              </a:spcAft>
+            </a:pPr>
+            <a:r>
+              <a:rPr sz="800" b="0">
+                <a:solidFill>
+                  <a:srgbClr val="5B6677"/>
+                </a:solidFill>
+                <a:latin typeface="微软雅黑"/>
+                <a:ea typeface="微软雅黑"/>
+              </a:rPr>
+              <a:t>不达标即停,不进入开发</a:t>
+            </a:r>
+          </a:p>
+        </p:txBody>
+      </p:sp>
+      <p:sp>
+        <p:nvSpPr>
+          <p:cNvPr id="50" name="Oval 49"/>
+          <p:cNvSpPr/>
+          <p:nvPr/>
+        </p:nvSpPr>
+        <p:spPr>
+          <a:xfrm>
+            <a:off x="9720072" y="3310128"/>
+            <a:ext cx="274320" cy="274320"/>
+          </a:xfrm>
+          <a:prstGeom prst="ellipse">
+            <a:avLst/>
+          </a:prstGeom>
+          <a:solidFill>
+            <a:srgbClr val="FFFFFF"/>
+          </a:solidFill>
+          <a:ln w="15875">
+            <a:solidFill>
+              <a:srgbClr val="C00000"/>
+            </a:solidFill>
+          </a:ln>
+          <a:effectLst/>
+        </p:spPr>
+        <p:style>
+          <a:lnRef idx="1">
+            <a:schemeClr val="accent1"/>
+          </a:lnRef>
+          <a:fillRef idx="3">
+            <a:schemeClr val="accent1"/>
+          </a:fillRef>
+          <a:effectRef idx="2">
+            <a:schemeClr val="accent1"/>
+          </a:effectRef>
+          <a:fontRef idx="minor">
+            <a:schemeClr val="lt1"/>
+          </a:fontRef>
+        </p:style>
+        <p:txBody>
+          <a:bodyPr rtlCol="0" anchor="ctr" wrap="square" lIns="45720" rIns="45720" tIns="18288" bIns="18288"/>
+          <a:lstStyle/>
+          <a:p>
+            <a:pPr algn="ctr">
+              <a:spcBef>
+                <a:spcPts val="0"/>
+              </a:spcBef>
+              <a:spcAft>
+                <a:spcPts val="0"/>
+              </a:spcAft>
+            </a:pPr>
+            <a:r>
+              <a:rPr sz="1000" b="1">
+                <a:solidFill>
+                  <a:srgbClr val="C00000"/>
+                </a:solidFill>
+                <a:latin typeface="微软雅黑"/>
+                <a:ea typeface="微软雅黑"/>
+              </a:rPr>
+              <a:t>2</a:t>
+            </a:r>
+          </a:p>
+        </p:txBody>
+      </p:sp>
+      <p:sp>
+        <p:nvSpPr>
+          <p:cNvPr id="51" name="TextBox 50"/>
+          <p:cNvSpPr txBox="1"/>
+          <p:nvPr/>
+        </p:nvSpPr>
+        <p:spPr>
+          <a:xfrm>
+            <a:off x="10058400" y="3255264"/>
+            <a:ext cx="1773936" cy="1005840"/>
+          </a:xfrm>
+          <a:prstGeom prst="rect">
+            <a:avLst/>
+          </a:prstGeom>
+          <a:noFill/>
+        </p:spPr>
+        <p:txBody>
+          <a:bodyPr wrap="square">
+            <a:spAutoFit/>
+          </a:bodyPr>
+          <a:lstStyle/>
+          <a:p>
+            <a:pPr algn="l">
+              <a:spcBef>
+                <a:spcPts val="0"/>
+              </a:spcBef>
+              <a:spcAft>
+                <a:spcPts val="0"/>
+              </a:spcAft>
+            </a:pPr>
+            <a:r>
+              <a:rPr sz="1150" b="1">
+                <a:solidFill>
+                  <a:srgbClr val="C00000"/>
+                </a:solidFill>
+                <a:latin typeface="微软雅黑"/>
+                <a:ea typeface="微软雅黑"/>
+              </a:rPr>
+              <a:t>T+3 周</a:t>
+            </a:r>
+          </a:p>
+          <a:p>
+            <a:pPr algn="l">
+              <a:spcBef>
+                <a:spcPts val="100"/>
+              </a:spcBef>
+              <a:spcAft>
+                <a:spcPts val="0"/>
+              </a:spcAft>
+            </a:pPr>
+            <a:r>
+              <a:rPr sz="1000" b="1">
+                <a:solidFill>
+                  <a:srgbClr val="1B222E"/>
+                </a:solidFill>
+                <a:latin typeface="微软雅黑"/>
+                <a:ea typeface="微软雅黑"/>
+              </a:rPr>
+              <a:t>G2 · 打通信号</a:t>
+            </a:r>
+          </a:p>
+          <a:p>
+            <a:pPr algn="l">
+              <a:spcBef>
+                <a:spcPts val="100"/>
+              </a:spcBef>
+              <a:spcAft>
+                <a:spcPts val="0"/>
+              </a:spcAft>
+            </a:pPr>
+            <a:r>
+              <a:rPr sz="800" b="0">
+                <a:solidFill>
+                  <a:srgbClr val="5B6677"/>
+                </a:solidFill>
+                <a:latin typeface="微软雅黑"/>
+                <a:ea typeface="微软雅黑"/>
+              </a:rPr>
+              <a:t>vllm-ascend 加载置信度头</a:t>
+            </a:r>
+          </a:p>
+          <a:p>
+            <a:pPr algn="l">
+              <a:spcBef>
+                <a:spcPts val="100"/>
+              </a:spcBef>
+              <a:spcAft>
+                <a:spcPts val="0"/>
+              </a:spcAft>
+            </a:pPr>
+            <a:r>
+              <a:rPr sz="800" b="0">
+                <a:solidFill>
+                  <a:srgbClr val="5B6677"/>
+                </a:solidFill>
+                <a:latin typeface="微软雅黑"/>
+                <a:ea typeface="微软雅黑"/>
+              </a:rPr>
+              <a:t>端到端读出逐位置信度</a:t>
+            </a:r>
+          </a:p>
+          <a:p>
+            <a:pPr algn="l">
+              <a:spcBef>
+                <a:spcPts val="100"/>
+              </a:spcBef>
+              <a:spcAft>
+                <a:spcPts val="0"/>
+              </a:spcAft>
+            </a:pPr>
+            <a:r>
+              <a:rPr sz="800" b="0">
+                <a:solidFill>
+                  <a:srgbClr val="5B6677"/>
+                </a:solidFill>
+                <a:latin typeface="微软雅黑"/>
+                <a:ea typeface="微软雅黑"/>
+              </a:rPr>
+              <a:t>与实测接受率做相关性验证</a:t>
+            </a:r>
+          </a:p>
+        </p:txBody>
+      </p:sp>
+      <p:sp>
+        <p:nvSpPr>
+          <p:cNvPr id="52" name="Oval 51"/>
+          <p:cNvSpPr/>
+          <p:nvPr/>
+        </p:nvSpPr>
+        <p:spPr>
+          <a:xfrm>
+            <a:off x="9720072" y="4370831"/>
+            <a:ext cx="274320" cy="274320"/>
+          </a:xfrm>
+          <a:prstGeom prst="ellipse">
+            <a:avLst/>
+          </a:prstGeom>
+          <a:solidFill>
+            <a:srgbClr val="FFFFFF"/>
+          </a:solidFill>
+          <a:ln w="15875">
+            <a:solidFill>
+              <a:srgbClr val="C00000"/>
+            </a:solidFill>
+          </a:ln>
+          <a:effectLst/>
+        </p:spPr>
+        <p:style>
+          <a:lnRef idx="1">
+            <a:schemeClr val="accent1"/>
+          </a:lnRef>
+          <a:fillRef idx="3">
+            <a:schemeClr val="accent1"/>
+          </a:fillRef>
+          <a:effectRef idx="2">
+            <a:schemeClr val="accent1"/>
+          </a:effectRef>
+          <a:fontRef idx="minor">
+            <a:schemeClr val="lt1"/>
+          </a:fontRef>
+        </p:style>
+        <p:txBody>
+          <a:bodyPr rtlCol="0" anchor="ctr" wrap="square" lIns="45720" rIns="45720" tIns="18288" bIns="18288"/>
+          <a:lstStyle/>
+          <a:p>
+            <a:pPr algn="ctr">
+              <a:spcBef>
+                <a:spcPts val="0"/>
+              </a:spcBef>
+              <a:spcAft>
+                <a:spcPts val="0"/>
+              </a:spcAft>
+            </a:pPr>
+            <a:r>
+              <a:rPr sz="1000" b="1">
+                <a:solidFill>
+                  <a:srgbClr val="C00000"/>
+                </a:solidFill>
+                <a:latin typeface="微软雅黑"/>
+                <a:ea typeface="微软雅黑"/>
+              </a:rPr>
+              <a:t>3</a:t>
+            </a:r>
+          </a:p>
+        </p:txBody>
+      </p:sp>
+      <p:sp>
+        <p:nvSpPr>
+          <p:cNvPr id="53" name="TextBox 52"/>
+          <p:cNvSpPr txBox="1"/>
+          <p:nvPr/>
+        </p:nvSpPr>
+        <p:spPr>
+          <a:xfrm>
+            <a:off x="10058400" y="4315968"/>
+            <a:ext cx="1773936" cy="1005840"/>
+          </a:xfrm>
+          <a:prstGeom prst="rect">
+            <a:avLst/>
+          </a:prstGeom>
+          <a:noFill/>
+        </p:spPr>
+        <p:txBody>
+          <a:bodyPr wrap="square">
+            <a:spAutoFit/>
+          </a:bodyPr>
+          <a:lstStyle/>
+          <a:p>
+            <a:pPr algn="l">
+              <a:spcBef>
+                <a:spcPts val="0"/>
+              </a:spcBef>
+              <a:spcAft>
+                <a:spcPts val="0"/>
+              </a:spcAft>
+            </a:pPr>
+            <a:r>
+              <a:rPr sz="1150" b="1">
+                <a:solidFill>
+                  <a:srgbClr val="C00000"/>
+                </a:solidFill>
+                <a:latin typeface="微软雅黑"/>
+                <a:ea typeface="微软雅黑"/>
+              </a:rPr>
+              <a:t>T+11 周</a:t>
+            </a:r>
+          </a:p>
+          <a:p>
+            <a:pPr algn="l">
+              <a:spcBef>
+                <a:spcPts val="100"/>
+              </a:spcBef>
+              <a:spcAft>
+                <a:spcPts val="0"/>
+              </a:spcAft>
+            </a:pPr>
+            <a:r>
+              <a:rPr sz="1000" b="1">
+                <a:solidFill>
+                  <a:srgbClr val="1B222E"/>
+                </a:solidFill>
+                <a:latin typeface="微软雅黑"/>
+                <a:ea typeface="微软雅黑"/>
+              </a:rPr>
+              <a:t>G3 · 图模式 ★</a:t>
+            </a:r>
+          </a:p>
+          <a:p>
+            <a:pPr algn="l">
+              <a:spcBef>
+                <a:spcPts val="100"/>
+              </a:spcBef>
+              <a:spcAft>
+                <a:spcPts val="0"/>
+              </a:spcAft>
+            </a:pPr>
+            <a:r>
+              <a:rPr sz="800" b="0">
+                <a:solidFill>
+                  <a:srgbClr val="5B6677"/>
+                </a:solidFill>
+                <a:latin typeface="微软雅黑"/>
+                <a:ea typeface="微软雅黑"/>
+              </a:rPr>
+              <a:t>动态 K 在图模式下运行</a:t>
+            </a:r>
+          </a:p>
+          <a:p>
+            <a:pPr algn="l">
+              <a:spcBef>
+                <a:spcPts val="100"/>
+              </a:spcBef>
+              <a:spcAft>
+                <a:spcPts val="0"/>
+              </a:spcAft>
+            </a:pPr>
+            <a:r>
+              <a:rPr sz="800" b="0">
+                <a:solidFill>
+                  <a:srgbClr val="5B6677"/>
+                </a:solidFill>
+                <a:latin typeface="微软雅黑"/>
+                <a:ea typeface="微软雅黑"/>
+              </a:rPr>
+              <a:t>端到端不劣于同预算固定 K</a:t>
+            </a:r>
+          </a:p>
+          <a:p>
+            <a:pPr algn="l">
+              <a:spcBef>
+                <a:spcPts val="100"/>
+              </a:spcBef>
+              <a:spcAft>
+                <a:spcPts val="0"/>
+              </a:spcAft>
+            </a:pPr>
+            <a:r>
+              <a:rPr sz="800" b="0">
+                <a:solidFill>
+                  <a:srgbClr val="5B6677"/>
+                </a:solidFill>
+                <a:latin typeface="微软雅黑"/>
+                <a:ea typeface="微软雅黑"/>
+              </a:rPr>
+              <a:t>本项目主要技术风险所在</a:t>
+            </a:r>
+          </a:p>
+        </p:txBody>
+      </p:sp>
+      <p:sp>
+        <p:nvSpPr>
+          <p:cNvPr id="54" name="Oval 53"/>
+          <p:cNvSpPr/>
+          <p:nvPr/>
+        </p:nvSpPr>
+        <p:spPr>
+          <a:xfrm>
+            <a:off x="9720072" y="5431536"/>
+            <a:ext cx="274320" cy="274320"/>
+          </a:xfrm>
+          <a:prstGeom prst="ellipse">
+            <a:avLst/>
+          </a:prstGeom>
+          <a:solidFill>
+            <a:srgbClr val="FFFFFF"/>
+          </a:solidFill>
+          <a:ln w="15875">
+            <a:solidFill>
+              <a:srgbClr val="C00000"/>
+            </a:solidFill>
+          </a:ln>
+          <a:effectLst/>
+        </p:spPr>
+        <p:style>
+          <a:lnRef idx="1">
+            <a:schemeClr val="accent1"/>
+          </a:lnRef>
+          <a:fillRef idx="3">
+            <a:schemeClr val="accent1"/>
+          </a:fillRef>
+          <a:effectRef idx="2">
+            <a:schemeClr val="accent1"/>
+          </a:effectRef>
+          <a:fontRef idx="minor">
+            <a:schemeClr val="lt1"/>
+          </a:fontRef>
+        </p:style>
+        <p:txBody>
+          <a:bodyPr rtlCol="0" anchor="ctr" wrap="square" lIns="45720" rIns="45720" tIns="18288" bIns="18288"/>
+          <a:lstStyle/>
+          <a:p>
+            <a:pPr algn="ctr">
+              <a:spcBef>
+                <a:spcPts val="0"/>
+              </a:spcBef>
+              <a:spcAft>
+                <a:spcPts val="0"/>
+              </a:spcAft>
+            </a:pPr>
+            <a:r>
+              <a:rPr sz="1000" b="1">
+                <a:solidFill>
+                  <a:srgbClr val="C00000"/>
+                </a:solidFill>
+                <a:latin typeface="微软雅黑"/>
+                <a:ea typeface="微软雅黑"/>
+              </a:rPr>
+              <a:t>4</a:t>
+            </a:r>
+          </a:p>
+        </p:txBody>
+      </p:sp>
+      <p:sp>
+        <p:nvSpPr>
+          <p:cNvPr id="55" name="TextBox 54"/>
+          <p:cNvSpPr txBox="1"/>
+          <p:nvPr/>
+        </p:nvSpPr>
+        <p:spPr>
+          <a:xfrm>
+            <a:off x="10058400" y="5376672"/>
+            <a:ext cx="1773936" cy="1005840"/>
+          </a:xfrm>
+          <a:prstGeom prst="rect">
+            <a:avLst/>
+          </a:prstGeom>
+          <a:noFill/>
+        </p:spPr>
+        <p:txBody>
+          <a:bodyPr wrap="square">
+            <a:spAutoFit/>
+          </a:bodyPr>
+          <a:lstStyle/>
+          <a:p>
+            <a:pPr algn="l">
+              <a:spcBef>
+                <a:spcPts val="0"/>
+              </a:spcBef>
+              <a:spcAft>
+                <a:spcPts val="0"/>
+              </a:spcAft>
+            </a:pPr>
+            <a:r>
+              <a:rPr sz="1150" b="1">
+                <a:solidFill>
+                  <a:srgbClr val="C00000"/>
+                </a:solidFill>
+                <a:latin typeface="微软雅黑"/>
+                <a:ea typeface="微软雅黑"/>
+              </a:rPr>
+              <a:t>T+15 周</a:t>
+            </a:r>
+          </a:p>
+          <a:p>
+            <a:pPr algn="l">
+              <a:spcBef>
+                <a:spcPts val="100"/>
+              </a:spcBef>
+              <a:spcAft>
+                <a:spcPts val="0"/>
+              </a:spcAft>
+            </a:pPr>
+            <a:r>
+              <a:rPr sz="1000" b="1">
+                <a:solidFill>
+                  <a:srgbClr val="1B222E"/>
+                </a:solidFill>
+                <a:latin typeface="微软雅黑"/>
+                <a:ea typeface="微软雅黑"/>
+              </a:rPr>
+              <a:t>合入与扩展</a:t>
+            </a:r>
+          </a:p>
+          <a:p>
+            <a:pPr algn="l">
+              <a:spcBef>
+                <a:spcPts val="100"/>
+              </a:spcBef>
+              <a:spcAft>
+                <a:spcPts val="0"/>
+              </a:spcAft>
+            </a:pPr>
+            <a:r>
+              <a:rPr sz="800" b="0">
+                <a:solidFill>
+                  <a:srgbClr val="5B6677"/>
+                </a:solidFill>
+                <a:latin typeface="微软雅黑"/>
+                <a:ea typeface="微软雅黑"/>
+              </a:rPr>
+              <a:t>推广到通用模型路径</a:t>
+            </a:r>
+          </a:p>
+          <a:p>
+            <a:pPr algn="l">
+              <a:spcBef>
+                <a:spcPts val="100"/>
+              </a:spcBef>
+              <a:spcAft>
+                <a:spcPts val="0"/>
+              </a:spcAft>
+            </a:pPr>
+            <a:r>
+              <a:rPr sz="800" b="0">
+                <a:solidFill>
+                  <a:srgbClr val="5B6677"/>
+                </a:solidFill>
+                <a:latin typeface="微软雅黑"/>
+                <a:ea typeface="微软雅黑"/>
+              </a:rPr>
+              <a:t>补齐限制项 + 复现文档</a:t>
+            </a:r>
+          </a:p>
+        </p:txBody>
+      </p:sp>
+      <p:sp>
+        <p:nvSpPr>
+          <p:cNvPr id="56" name="TextBox 55"/>
+          <p:cNvSpPr txBox="1"/>
+          <p:nvPr/>
+        </p:nvSpPr>
+        <p:spPr>
+          <a:xfrm>
+            <a:off x="9637776" y="6455664"/>
+            <a:ext cx="2231136" cy="310896"/>
+          </a:xfrm>
+          <a:prstGeom prst="rect">
+            <a:avLst/>
+          </a:prstGeom>
+          <a:noFill/>
+        </p:spPr>
+        <p:txBody>
+          <a:bodyPr wrap="square">
+            <a:spAutoFit/>
+          </a:bodyPr>
+          <a:lstStyle/>
+          <a:p>
+            <a:pPr algn="l">
+              <a:spcBef>
+                <a:spcPts val="0"/>
+              </a:spcBef>
+              <a:spcAft>
+                <a:spcPts val="0"/>
+              </a:spcAft>
+            </a:pPr>
+            <a:r>
+              <a:rPr sz="750" b="0">
+                <a:solidFill>
+                  <a:srgbClr val="5B6677"/>
+                </a:solidFill>
+                <a:latin typeface="微软雅黑"/>
+                <a:ea typeface="微软雅黑"/>
+              </a:rPr>
+              <a:t>T = 立项批准日;绝对日期待排期确定后填入</a:t>
+            </a:r>
+          </a:p>
+        </p:txBody>
+      </p:sp>
+    </p:spTree>
+  </p:cSld>
+  <p:clrMapOvr>
+    <a:masterClrMapping/>
+  </p:clrMapOvr>
+</p:sld>
+</file>
+
+<file path=ppt/slides/slide3.xml><?xml version="1.0" encoding="utf-8"?>
+<p:sld xmlns:a="http://schemas.openxmlformats.org/drawingml/2006/main" xmlns:p="http://schemas.openxmlformats.org/presentationml/2006/main" xmlns:r="http://schemas.openxmlformats.org/officeDocument/2006/relationships">
+  <p:cSld>
+    <p:bg>
+      <p:bgPr>
+        <a:solidFill>
+          <a:srgbClr val="FFFFFF"/>
+        </a:solidFill>
+        <a:effectLst/>
+      </p:bgPr>
+    </p:bg>
+    <p:spTree>
+      <p:nvGrpSpPr>
+        <p:cNvPr id="1" name=""/>
+        <p:cNvGrpSpPr/>
+        <p:nvPr/>
+      </p:nvGrpSpPr>
+      <p:grpSpPr/>
+      <p:sp>
+        <p:nvSpPr>
+          <p:cNvPr id="2" name="TextBox 1"/>
+          <p:cNvSpPr txBox="1"/>
+          <p:nvPr/>
+        </p:nvSpPr>
+        <p:spPr>
+          <a:xfrm>
             <a:off x="502920" y="256032"/>
             <a:ext cx="11247120" cy="868680"/>
           </a:xfrm>
@@ -4101,7 +7779,7 @@
 </p:sld>
 </file>
 
-<file path=ppt/slides/slide3.xml><?xml version="1.0" encoding="utf-8"?>
+<file path=ppt/slides/slide4.xml><?xml version="1.0" encoding="utf-8"?>
 <p:sld xmlns:a="http://schemas.openxmlformats.org/drawingml/2006/main" xmlns:p="http://schemas.openxmlformats.org/presentationml/2006/main" xmlns:r="http://schemas.openxmlformats.org/officeDocument/2006/relationships">
   <p:cSld>
     <p:bg>
@@ -4979,7 +8657,7 @@
 </p:sld>
 </file>
 
-<file path=ppt/slides/slide4.xml><?xml version="1.0" encoding="utf-8"?>
+<file path=ppt/slides/slide5.xml><?xml version="1.0" encoding="utf-8"?>
 <p:sld xmlns:a="http://schemas.openxmlformats.org/drawingml/2006/main" xmlns:p="http://schemas.openxmlformats.org/presentationml/2006/main" xmlns:r="http://schemas.openxmlformats.org/officeDocument/2006/relationships">
   <p:cSld>
     <p:bg>
@@ -5907,7 +9585,7 @@
 </p:sld>
 </file>
 
-<file path=ppt/slides/slide5.xml><?xml version="1.0" encoding="utf-8"?>
+<file path=ppt/slides/slide6.xml><?xml version="1.0" encoding="utf-8"?>
 <p:sld xmlns:a="http://schemas.openxmlformats.org/drawingml/2006/main" xmlns:p="http://schemas.openxmlformats.org/presentationml/2006/main" xmlns:r="http://schemas.openxmlformats.org/officeDocument/2006/relationships">
   <p:cSld>
     <p:bg>
@@ -6961,7 +10639,7 @@
 </p:sld>
 </file>
 
-<file path=ppt/slides/slide6.xml><?xml version="1.0" encoding="utf-8"?>
+<file path=ppt/slides/slide7.xml><?xml version="1.0" encoding="utf-8"?>
 <p:sld xmlns:a="http://schemas.openxmlformats.org/drawingml/2006/main" xmlns:p="http://schemas.openxmlformats.org/presentationml/2006/main" xmlns:r="http://schemas.openxmlformats.org/officeDocument/2006/relationships">
   <p:cSld>
     <p:bg>
@@ -7756,7 +11434,7 @@
 </p:sld>
 </file>
 
-<file path=ppt/slides/slide7.xml><?xml version="1.0" encoding="utf-8"?>
+<file path=ppt/slides/slide8.xml><?xml version="1.0" encoding="utf-8"?>
 <p:sld xmlns:a="http://schemas.openxmlformats.org/drawingml/2006/main" xmlns:p="http://schemas.openxmlformats.org/presentationml/2006/main" xmlns:r="http://schemas.openxmlformats.org/officeDocument/2006/relationships">
   <p:cSld>
     <p:bg>

</xml_diff>

<commit_message>
docs(memo): put the red emphasis on the graph risk, not the confidence head
The one-pager flagged 'the confidence head is not loaded on Ascend' in red, which
contradicted the same deck's own gap table two slides later, where that gap is
graded small. It is small: upstream #47808 removes one line of drop logic and
adds a linear head.

The actual challenge is the one after that: K_i varies per step, so if it cannot
be captured in a graph, adaptive speculation can end up slower than fixed K even
once it works. That line is now the red one, and the loop-back annotations in
the left column split accordingly -- signal unusable is a muted note, 'cannot
enter the graph -> fall back to eager' is the red one.
</commit_message>
<xml_diff>
--- a/docs/memos/adaptive-spec-project-proposal-v3.pptx
+++ b/docs/memos/adaptive-spec-project-proposal-v3.pptx
@@ -3427,12 +3427,12 @@
             <a:r>
               <a:rPr sz="1050" b="0">
                 <a:solidFill>
-                  <a:srgbClr val="1B222E"/>
+                  <a:srgbClr val="C00000"/>
                 </a:solidFill>
                 <a:latin typeface="微软雅黑"/>
                 <a:ea typeface="微软雅黑"/>
               </a:rPr>
-              <a:t>· 变长 K_i 与设备图「形状固定」天然冲突,昇腾当前按固定形状捕获</a:t>
+              <a:t>★ 变长 K_i 与设备图「形状固定」冲突 —— 若进不了图,即便自适应实现了,性能仍可能不如固定 K</a:t>
             </a:r>
           </a:p>
           <a:p>
@@ -3447,12 +3447,12 @@
             <a:r>
               <a:rPr sz="1050" b="0">
                 <a:solidFill>
-                  <a:srgbClr val="C00000"/>
+                  <a:srgbClr val="5B6677"/>
                 </a:solidFill>
                 <a:latin typeface="微软雅黑"/>
                 <a:ea typeface="微软雅黑"/>
               </a:rPr>
-              <a:t>· 昇腾侧 confidence head 根本未被加载,调度所需的信号拿不到</a:t>
+              <a:t>· confidence head 在昇腾侧尚未加载(短期缺项,移植上游改法即可,非难点)</a:t>
             </a:r>
           </a:p>
         </p:txBody>
@@ -4634,8 +4634,8 @@
         </p:nvSpPr>
         <p:spPr>
           <a:xfrm>
-            <a:off x="274320" y="6291072"/>
-            <a:ext cx="2395728" cy="457200"/>
+            <a:off x="274320" y="6254496"/>
+            <a:ext cx="2395728" cy="512064"/>
           </a:xfrm>
           <a:prstGeom prst="rect">
             <a:avLst/>
@@ -4659,12 +4659,32 @@
             <a:r>
               <a:rPr sz="800" b="0">
                 <a:solidFill>
-                  <a:srgbClr val="C00000"/>
+                  <a:srgbClr val="5B6677"/>
                 </a:solidFill>
                 <a:latin typeface="微软雅黑"/>
                 <a:ea typeface="微软雅黑"/>
               </a:rPr>
-              <a:t>信号不可用 → 回草稿侧重拟合置信度头</a:t>
+              <a:t>① 信号不可用 → 回草稿侧重拟合置信度头</a:t>
+            </a:r>
+          </a:p>
+          <a:p>
+            <a:pPr algn="l">
+              <a:spcBef>
+                <a:spcPts val="100"/>
+              </a:spcBef>
+              <a:spcAft>
+                <a:spcPts val="0"/>
+              </a:spcAft>
+            </a:pPr>
+            <a:r>
+              <a:rPr sz="800" b="0">
+                <a:solidFill>
+                  <a:srgbClr val="C00000"/>
+                </a:solidFill>
+                <a:latin typeface="微软雅黑"/>
+                <a:ea typeface="微软雅黑"/>
+              </a:rPr>
+              <a:t>② 进不了图 → 退回 eager,收益打折</a:t>
             </a:r>
           </a:p>
         </p:txBody>
@@ -9005,7 +9025,7 @@
                           <a:latin typeface="微软雅黑"/>
                           <a:ea typeface="微软雅黑"/>
                         </a:rPr>
-                        <a:t>根本没有被加载</a:t>
+                        <a:t>尚未加载(短期缺项)</a:t>
                       </a:r>
                     </a:p>
                   </a:txBody>
@@ -9127,7 +9147,7 @@
                           <a:latin typeface="微软雅黑"/>
                           <a:ea typeface="微软雅黑"/>
                         </a:rPr>
-                        <a:t>小 —— 移植上游改法即可。</a:t>
+                        <a:t>小 —— 非难点。上游改动仅为解除一行</a:t>
                       </a:r>
                     </a:p>
                     <a:p>
@@ -9147,7 +9167,7 @@
                           <a:latin typeface="微软雅黑"/>
                           <a:ea typeface="微软雅黑"/>
                         </a:rPr>
-                        <a:t>草稿侧我们已就位:训练已产出该头,</a:t>
+                        <a:t>丢弃逻辑 + 一个线性头。草稿侧我们已就位:</a:t>
                       </a:r>
                     </a:p>
                     <a:p>
@@ -9167,7 +9187,7 @@
                           <a:latin typeface="微软雅黑"/>
                           <a:ea typeface="微软雅黑"/>
                         </a:rPr>
-                        <a:t>且已按上游区分 bias(DSV4 无 / Qwen3 有)</a:t>
+                        <a:t>训练已产出该头,且已按上游区分 bias</a:t>
                       </a:r>
                     </a:p>
                   </a:txBody>

</xml_diff>

<commit_message>
docs(memo): make the one-pager's graph panel stand on its own
It ended on 'see the two supplementary slides', which is no use to anyone reading
only the summary sheet -- the one-pager is the page that gets circulated. It now
carries the conclusion itself: the fixed-vs-adaptive shape argument, then the
question it reduces to, then the answer per operator -- FIA v2 spelled out with
its full name and its host-side list, the DSA/SFA device tensor that DSV4 rides,
and the workspace cache keyed on token count that is the actual unknown.

Drops the 'what a device graph is' primer from this panel; that belongs on the
supplementary slide, and the summary sheet has no room to spend on it.
</commit_message>
<xml_diff>
--- a/docs/memos/adaptive-spec-project-proposal-v3.pptx
+++ b/docs/memos/adaptive-spec-project-proposal-v3.pptx
@@ -6785,8 +6785,8 @@
         </p:nvSpPr>
         <p:spPr>
           <a:xfrm>
-            <a:off x="6437375" y="4553712"/>
-            <a:ext cx="2962656" cy="1920240"/>
+            <a:off x="6400800" y="4517136"/>
+            <a:ext cx="3017520" cy="1920240"/>
           </a:xfrm>
           <a:prstGeom prst="rect">
             <a:avLst/>
@@ -6808,47 +6808,7 @@
               </a:spcAft>
             </a:pPr>
             <a:r>
-              <a:rPr sz="950" b="1">
-                <a:solidFill>
-                  <a:srgbClr val="1B222E"/>
-                </a:solidFill>
-                <a:latin typeface="微软雅黑"/>
-                <a:ea typeface="微软雅黑"/>
-              </a:rPr>
-              <a:t>为什么变长会掉出设备图</a:t>
-            </a:r>
-          </a:p>
-          <a:p>
-            <a:pPr algn="l">
-              <a:spcBef>
-                <a:spcPts val="200"/>
-              </a:spcBef>
-              <a:spcAft>
-                <a:spcPts val="0"/>
-              </a:spcAft>
-            </a:pPr>
-            <a:r>
-              <a:rPr sz="850" b="0">
-                <a:solidFill>
-                  <a:srgbClr val="1B222E"/>
-                </a:solidFill>
-                <a:latin typeface="微软雅黑"/>
-                <a:ea typeface="微软雅黑"/>
-              </a:rPr>
-              <a:t>· 设备图 = 把一串算子按固定的张量形状录制下来直接重放,省掉逐算子下发开销;录制的前提就是形状固定;</a:t>
-            </a:r>
-          </a:p>
-          <a:p>
-            <a:pPr algn="l">
-              <a:spcBef>
-                <a:spcPts val="200"/>
-              </a:spcBef>
-              <a:spcAft>
-                <a:spcPts val="0"/>
-              </a:spcAft>
-            </a:pPr>
-            <a:r>
-              <a:rPr sz="850" b="0">
+              <a:rPr sz="800" b="0">
                 <a:solidFill>
                   <a:srgbClr val="1B222E"/>
                 </a:solidFill>
@@ -6868,14 +6828,74 @@
               </a:spcAft>
             </a:pPr>
             <a:r>
-              <a:rPr sz="850" b="0">
+              <a:rPr sz="800" b="0">
+                <a:solidFill>
+                  <a:srgbClr val="1B222E"/>
+                </a:solidFill>
+                <a:latin typeface="微软雅黑"/>
+                <a:ea typeface="微软雅黑"/>
+              </a:rPr>
+              <a:t>· 能否留在图内,取决于图里的长度参数是「录制时固化的常量」还是「运行时可改的设备张量」:</a:t>
+            </a:r>
+          </a:p>
+          <a:p>
+            <a:pPr algn="l">
+              <a:spcBef>
+                <a:spcPts val="200"/>
+              </a:spcBef>
+              <a:spcAft>
+                <a:spcPts val="0"/>
+              </a:spcAft>
+            </a:pPr>
+            <a:r>
+              <a:rPr sz="800" b="0">
+                <a:solidFill>
+                  <a:srgbClr val="1B222E"/>
+                </a:solidFill>
+                <a:latin typeface="微软雅黑"/>
+                <a:ea typeface="微软雅黑"/>
+              </a:rPr>
+              <a:t>  通用路径 FIA v2(npu_fused_infer_attention_score_v2)—— 长度是 host 侧 list,录制即固化 → K 一变必须整图重录;</a:t>
+            </a:r>
+          </a:p>
+          <a:p>
+            <a:pPr algn="l">
+              <a:spcBef>
+                <a:spcPts val="200"/>
+              </a:spcBef>
+              <a:spcAft>
+                <a:spcPts val="0"/>
+              </a:spcAft>
+            </a:pPr>
+            <a:r>
+              <a:rPr sz="800" b="0">
+                <a:solidFill>
+                  <a:srgbClr val="1B222E"/>
+                </a:solidFill>
+                <a:latin typeface="微软雅黑"/>
+                <a:ea typeface="微软雅黑"/>
+              </a:rPr>
+              <a:t>  ★ DSV4 路径 DSA / SFA —— 长度是 device tensor,图里存的是指针 → 改内容即可,结构上无需重录(有利条件);</a:t>
+            </a:r>
+          </a:p>
+          <a:p>
+            <a:pPr algn="l">
+              <a:spcBef>
+                <a:spcPts val="200"/>
+              </a:spcBef>
+              <a:spcAft>
+                <a:spcPts val="0"/>
+              </a:spcAft>
+            </a:pPr>
+            <a:r>
+              <a:rPr sz="800" b="0">
                 <a:solidFill>
                   <a:srgbClr val="C00000"/>
                 </a:solidFill>
                 <a:latin typeface="微软雅黑"/>
                 <a:ea typeface="微软雅黑"/>
               </a:rPr>
-              <a:t>· 能否留在图内,取决于图里的长度参数是「录制时固化的常量」还是「运行时可改的设备张量」 —— DSV4 属于后者(有利)。详见「三(补充)」两页。</a:t>
+              <a:t>· ★ 真正的未知量:workspace(算子临时显存)按 token 数做缓存键,K 一变即未命中、重新分配 → 图与 workspace 数量随 K 组合膨胀,显存与捕获耗时随之上升。</a:t>
             </a:r>
           </a:p>
         </p:txBody>

</xml_diff>

<commit_message>
docs(memo): attach each fallback note to the loop it belongs to
The two red lines sat at the bottom of the left column, detached from the loops
they annotate, so they read as two unexplained arrows -- the reader has to guess
which loop each one closes. In the format this page follows, that red text sits
beside the loop-back arrow it describes.

Each is now inside its own loop box: the confidence loop carries 'confidence
does not correlate with acceptance -> re-fit on the draft side (minutes)', the
graph loop carries 'variable length cannot be captured -> fall back to eager,
losing the graph-replay gain'. The second also names what the loss actually is
rather than saying the benefit is reduced.
</commit_message>
<xml_diff>
--- a/docs/memos/adaptive-spec-project-proposal-v3.pptx
+++ b/docs/memos/adaptive-spec-project-proposal-v3.pptx
@@ -4680,7 +4680,7 @@
         <p:spPr>
           <a:xfrm>
             <a:off x="292608" y="2487168"/>
-            <a:ext cx="2304288" cy="1572768"/>
+            <a:ext cx="2304288" cy="1755648"/>
           </a:xfrm>
           <a:prstGeom prst="rect">
             <a:avLst/>
@@ -5053,45 +5053,44 @@
       </p:sp>
       <p:sp>
         <p:nvSpPr>
-          <p:cNvPr id="16" name="Down Arrow 15"/>
-          <p:cNvSpPr/>
+          <p:cNvPr id="16" name="TextBox 15"/>
+          <p:cNvSpPr txBox="1"/>
           <p:nvPr/>
         </p:nvSpPr>
         <p:spPr>
           <a:xfrm>
-            <a:off x="1399032" y="4087368"/>
-            <a:ext cx="91440" cy="91440"/>
+            <a:off x="402336" y="3950208"/>
+            <a:ext cx="2084832" cy="256032"/>
           </a:xfrm>
-          <a:prstGeom prst="downArrow">
+          <a:prstGeom prst="rect">
             <a:avLst/>
           </a:prstGeom>
-          <a:solidFill>
-            <a:srgbClr val="1B222E"/>
-          </a:solidFill>
-          <a:ln>
-            <a:noFill/>
-          </a:ln>
-          <a:effectLst/>
+          <a:noFill/>
         </p:spPr>
-        <p:style>
-          <a:lnRef idx="1">
-            <a:schemeClr val="accent1"/>
-          </a:lnRef>
-          <a:fillRef idx="3">
-            <a:schemeClr val="accent1"/>
-          </a:fillRef>
-          <a:effectRef idx="2">
-            <a:schemeClr val="accent1"/>
-          </a:effectRef>
-          <a:fontRef idx="minor">
-            <a:schemeClr val="lt1"/>
-          </a:fontRef>
-        </p:style>
-        <p:txBody>
-          <a:bodyPr rtlCol="0" anchor="ctr"/>
-          <a:lstStyle/>
-          <a:p>
-            <a:pPr algn="ctr"/>
+        <p:txBody>
+          <a:bodyPr wrap="square">
+            <a:spAutoFit/>
+          </a:bodyPr>
+          <a:lstStyle/>
+          <a:p>
+            <a:pPr algn="l">
+              <a:spcBef>
+                <a:spcPts val="0"/>
+              </a:spcBef>
+              <a:spcAft>
+                <a:spcPts val="0"/>
+              </a:spcAft>
+            </a:pPr>
+            <a:r>
+              <a:rPr sz="750" b="0">
+                <a:solidFill>
+                  <a:srgbClr val="C00000"/>
+                </a:solidFill>
+                <a:latin typeface="微软雅黑"/>
+                <a:ea typeface="微软雅黑"/>
+              </a:rPr>
+              <a:t>⚠ 置信度与接受率不相关 → 回草稿侧重拟合(分钟级)</a:t>
+            </a:r>
           </a:p>
         </p:txBody>
       </p:sp>
@@ -5103,8 +5102,8 @@
         </p:nvSpPr>
         <p:spPr>
           <a:xfrm>
-            <a:off x="292608" y="4224528"/>
-            <a:ext cx="2304288" cy="1572768"/>
+            <a:off x="292608" y="4407408"/>
+            <a:ext cx="2304288" cy="1755648"/>
           </a:xfrm>
           <a:prstGeom prst="rect">
             <a:avLst/>
@@ -5147,7 +5146,7 @@
         </p:nvSpPr>
         <p:spPr>
           <a:xfrm>
-            <a:off x="347472" y="4279392"/>
+            <a:off x="347472" y="4462272"/>
             <a:ext cx="2194560" cy="256032"/>
           </a:xfrm>
           <a:prstGeom prst="rect">
@@ -5206,7 +5205,7 @@
         </p:nvSpPr>
         <p:spPr>
           <a:xfrm>
-            <a:off x="420624" y="4572000"/>
+            <a:off x="420624" y="4754880"/>
             <a:ext cx="2048256" cy="292608"/>
           </a:xfrm>
           <a:prstGeom prst="rect">
@@ -5269,7 +5268,7 @@
         </p:nvSpPr>
         <p:spPr>
           <a:xfrm>
-            <a:off x="1399032" y="4873752"/>
+            <a:off x="1399032" y="5056632"/>
             <a:ext cx="91440" cy="73152"/>
           </a:xfrm>
           <a:prstGeom prst="downArrow">
@@ -5313,7 +5312,7 @@
         </p:nvSpPr>
         <p:spPr>
           <a:xfrm>
-            <a:off x="420624" y="4956048"/>
+            <a:off x="420624" y="5138928"/>
             <a:ext cx="2048256" cy="292608"/>
           </a:xfrm>
           <a:prstGeom prst="rect">
@@ -5376,7 +5375,7 @@
         </p:nvSpPr>
         <p:spPr>
           <a:xfrm>
-            <a:off x="1399032" y="5257800"/>
+            <a:off x="1399032" y="5440680"/>
             <a:ext cx="91440" cy="73152"/>
           </a:xfrm>
           <a:prstGeom prst="downArrow">
@@ -5420,7 +5419,7 @@
         </p:nvSpPr>
         <p:spPr>
           <a:xfrm>
-            <a:off x="420624" y="5340096"/>
+            <a:off x="420624" y="5522976"/>
             <a:ext cx="2048256" cy="292608"/>
           </a:xfrm>
           <a:prstGeom prst="rect">
@@ -5477,14 +5476,101 @@
       </p:sp>
       <p:sp>
         <p:nvSpPr>
-          <p:cNvPr id="24" name="Rectangle 23"/>
+          <p:cNvPr id="24" name="TextBox 23"/>
+          <p:cNvSpPr txBox="1"/>
+          <p:nvPr/>
+        </p:nvSpPr>
+        <p:spPr>
+          <a:xfrm>
+            <a:off x="402336" y="5870448"/>
+            <a:ext cx="2084832" cy="256032"/>
+          </a:xfrm>
+          <a:prstGeom prst="rect">
+            <a:avLst/>
+          </a:prstGeom>
+          <a:noFill/>
+        </p:spPr>
+        <p:txBody>
+          <a:bodyPr wrap="square">
+            <a:spAutoFit/>
+          </a:bodyPr>
+          <a:lstStyle/>
+          <a:p>
+            <a:pPr algn="l">
+              <a:spcBef>
+                <a:spcPts val="0"/>
+              </a:spcBef>
+              <a:spcAft>
+                <a:spcPts val="0"/>
+              </a:spcAft>
+            </a:pPr>
+            <a:r>
+              <a:rPr sz="750" b="0">
+                <a:solidFill>
+                  <a:srgbClr val="C00000"/>
+                </a:solidFill>
+                <a:latin typeface="微软雅黑"/>
+                <a:ea typeface="微软雅黑"/>
+              </a:rPr>
+              <a:t>⚠ 变长进不了图 → 退回 eager,失去图重放收益</a:t>
+            </a:r>
+          </a:p>
+        </p:txBody>
+      </p:sp>
+      <p:sp>
+        <p:nvSpPr>
+          <p:cNvPr id="25" name="Down Arrow 24"/>
           <p:cNvSpPr/>
           <p:nvPr/>
         </p:nvSpPr>
         <p:spPr>
           <a:xfrm>
-            <a:off x="292608" y="5907024"/>
-            <a:ext cx="2304288" cy="329184"/>
+            <a:off x="1399032" y="4279392"/>
+            <a:ext cx="91440" cy="91440"/>
+          </a:xfrm>
+          <a:prstGeom prst="downArrow">
+            <a:avLst/>
+          </a:prstGeom>
+          <a:solidFill>
+            <a:srgbClr val="1B222E"/>
+          </a:solidFill>
+          <a:ln>
+            <a:noFill/>
+          </a:ln>
+          <a:effectLst/>
+        </p:spPr>
+        <p:style>
+          <a:lnRef idx="1">
+            <a:schemeClr val="accent1"/>
+          </a:lnRef>
+          <a:fillRef idx="3">
+            <a:schemeClr val="accent1"/>
+          </a:fillRef>
+          <a:effectRef idx="2">
+            <a:schemeClr val="accent1"/>
+          </a:effectRef>
+          <a:fontRef idx="minor">
+            <a:schemeClr val="lt1"/>
+          </a:fontRef>
+        </p:style>
+        <p:txBody>
+          <a:bodyPr rtlCol="0" anchor="ctr"/>
+          <a:lstStyle/>
+          <a:p>
+            <a:pPr algn="ctr"/>
+          </a:p>
+        </p:txBody>
+      </p:sp>
+      <p:sp>
+        <p:nvSpPr>
+          <p:cNvPr id="26" name="Rectangle 25"/>
+          <p:cNvSpPr/>
+          <p:nvPr/>
+        </p:nvSpPr>
+        <p:spPr>
+          <a:xfrm>
+            <a:off x="292608" y="6272784"/>
+            <a:ext cx="2304288" cy="310896"/>
           </a:xfrm>
           <a:prstGeom prst="rect">
             <a:avLst/>
@@ -5538,70 +5624,7 @@
       </p:sp>
       <p:sp>
         <p:nvSpPr>
-          <p:cNvPr id="25" name="TextBox 24"/>
-          <p:cNvSpPr txBox="1"/>
-          <p:nvPr/>
-        </p:nvSpPr>
-        <p:spPr>
-          <a:xfrm>
-            <a:off x="274320" y="6254496"/>
-            <a:ext cx="2395728" cy="512064"/>
-          </a:xfrm>
-          <a:prstGeom prst="rect">
-            <a:avLst/>
-          </a:prstGeom>
-          <a:noFill/>
-        </p:spPr>
-        <p:txBody>
-          <a:bodyPr wrap="square">
-            <a:spAutoFit/>
-          </a:bodyPr>
-          <a:lstStyle/>
-          <a:p>
-            <a:pPr algn="l">
-              <a:spcBef>
-                <a:spcPts val="0"/>
-              </a:spcBef>
-              <a:spcAft>
-                <a:spcPts val="0"/>
-              </a:spcAft>
-            </a:pPr>
-            <a:r>
-              <a:rPr sz="800" b="0">
-                <a:solidFill>
-                  <a:srgbClr val="5B6677"/>
-                </a:solidFill>
-                <a:latin typeface="微软雅黑"/>
-                <a:ea typeface="微软雅黑"/>
-              </a:rPr>
-              <a:t>① 信号不可用 → 回草稿侧重拟合置信度头</a:t>
-            </a:r>
-          </a:p>
-          <a:p>
-            <a:pPr algn="l">
-              <a:spcBef>
-                <a:spcPts val="100"/>
-              </a:spcBef>
-              <a:spcAft>
-                <a:spcPts val="0"/>
-              </a:spcAft>
-            </a:pPr>
-            <a:r>
-              <a:rPr sz="800" b="0">
-                <a:solidFill>
-                  <a:srgbClr val="C00000"/>
-                </a:solidFill>
-                <a:latin typeface="微软雅黑"/>
-                <a:ea typeface="微软雅黑"/>
-              </a:rPr>
-              <a:t>② 进不了图 → 退回 eager,收益打折</a:t>
-            </a:r>
-          </a:p>
-        </p:txBody>
-      </p:sp>
-      <p:sp>
-        <p:nvSpPr>
-          <p:cNvPr id="26" name="Rectangle 25"/>
+          <p:cNvPr id="27" name="Rectangle 26"/>
           <p:cNvSpPr/>
           <p:nvPr/>
         </p:nvSpPr>
@@ -5645,7 +5668,7 @@
       </p:sp>
       <p:sp>
         <p:nvSpPr>
-          <p:cNvPr id="27" name="TextBox 26"/>
+          <p:cNvPr id="28" name="TextBox 27"/>
           <p:cNvSpPr txBox="1"/>
           <p:nvPr/>
         </p:nvSpPr>
@@ -5688,7 +5711,7 @@
       </p:sp>
       <p:sp>
         <p:nvSpPr>
-          <p:cNvPr id="28" name="TextBox 27"/>
+          <p:cNvPr id="29" name="TextBox 28"/>
           <p:cNvSpPr txBox="1"/>
           <p:nvPr/>
         </p:nvSpPr>
@@ -5831,7 +5854,7 @@
       </p:sp>
       <p:sp>
         <p:nvSpPr>
-          <p:cNvPr id="29" name="Rectangle 28"/>
+          <p:cNvPr id="30" name="Rectangle 29"/>
           <p:cNvSpPr/>
           <p:nvPr/>
         </p:nvSpPr>
@@ -5914,7 +5937,7 @@
       </p:sp>
       <p:sp>
         <p:nvSpPr>
-          <p:cNvPr id="30" name="Right Arrow 29"/>
+          <p:cNvPr id="31" name="Right Arrow 30"/>
           <p:cNvSpPr/>
           <p:nvPr/>
         </p:nvSpPr>
@@ -5958,7 +5981,7 @@
       </p:sp>
       <p:sp>
         <p:nvSpPr>
-          <p:cNvPr id="31" name="Rectangle 30"/>
+          <p:cNvPr id="32" name="Rectangle 31"/>
           <p:cNvSpPr/>
           <p:nvPr/>
         </p:nvSpPr>
@@ -6041,7 +6064,7 @@
       </p:sp>
       <p:sp>
         <p:nvSpPr>
-          <p:cNvPr id="32" name="Right Arrow 31"/>
+          <p:cNvPr id="33" name="Right Arrow 32"/>
           <p:cNvSpPr/>
           <p:nvPr/>
         </p:nvSpPr>
@@ -6085,7 +6108,7 @@
       </p:sp>
       <p:sp>
         <p:nvSpPr>
-          <p:cNvPr id="33" name="Rectangle 32"/>
+          <p:cNvPr id="34" name="Rectangle 33"/>
           <p:cNvSpPr/>
           <p:nvPr/>
         </p:nvSpPr>
@@ -6168,7 +6191,7 @@
       </p:sp>
       <p:sp>
         <p:nvSpPr>
-          <p:cNvPr id="34" name="TextBox 33"/>
+          <p:cNvPr id="35" name="TextBox 34"/>
           <p:cNvSpPr txBox="1"/>
           <p:nvPr/>
         </p:nvSpPr>
@@ -6211,7 +6234,7 @@
       </p:sp>
       <p:sp>
         <p:nvSpPr>
-          <p:cNvPr id="35" name="Rectangle 34"/>
+          <p:cNvPr id="36" name="Rectangle 35"/>
           <p:cNvSpPr/>
           <p:nvPr/>
         </p:nvSpPr>
@@ -6272,7 +6295,7 @@
       </p:sp>
       <p:sp>
         <p:nvSpPr>
-          <p:cNvPr id="36" name="Rectangle 35"/>
+          <p:cNvPr id="37" name="Rectangle 36"/>
           <p:cNvSpPr/>
           <p:nvPr/>
         </p:nvSpPr>
@@ -6316,7 +6339,7 @@
       </p:sp>
       <p:sp>
         <p:nvSpPr>
-          <p:cNvPr id="37" name="TextBox 36"/>
+          <p:cNvPr id="38" name="TextBox 37"/>
           <p:cNvSpPr txBox="1"/>
           <p:nvPr/>
         </p:nvSpPr>
@@ -6359,7 +6382,7 @@
       </p:sp>
       <p:sp>
         <p:nvSpPr>
-          <p:cNvPr id="38" name="Rectangle 37"/>
+          <p:cNvPr id="39" name="Rectangle 38"/>
           <p:cNvSpPr/>
           <p:nvPr/>
         </p:nvSpPr>
@@ -6442,7 +6465,7 @@
       </p:sp>
       <p:sp>
         <p:nvSpPr>
-          <p:cNvPr id="39" name="Right Arrow 38"/>
+          <p:cNvPr id="40" name="Right Arrow 39"/>
           <p:cNvSpPr/>
           <p:nvPr/>
         </p:nvSpPr>
@@ -6486,7 +6509,7 @@
       </p:sp>
       <p:sp>
         <p:nvSpPr>
-          <p:cNvPr id="40" name="Rectangle 39"/>
+          <p:cNvPr id="41" name="Rectangle 40"/>
           <p:cNvSpPr/>
           <p:nvPr/>
         </p:nvSpPr>
@@ -6569,7 +6592,7 @@
       </p:sp>
       <p:sp>
         <p:nvSpPr>
-          <p:cNvPr id="41" name="Right Arrow 40"/>
+          <p:cNvPr id="42" name="Right Arrow 41"/>
           <p:cNvSpPr/>
           <p:nvPr/>
         </p:nvSpPr>
@@ -6613,7 +6636,7 @@
       </p:sp>
       <p:sp>
         <p:nvSpPr>
-          <p:cNvPr id="42" name="Rectangle 41"/>
+          <p:cNvPr id="43" name="Rectangle 42"/>
           <p:cNvSpPr/>
           <p:nvPr/>
         </p:nvSpPr>
@@ -6696,7 +6719,7 @@
       </p:sp>
       <p:sp>
         <p:nvSpPr>
-          <p:cNvPr id="43" name="TextBox 42"/>
+          <p:cNvPr id="44" name="TextBox 43"/>
           <p:cNvSpPr txBox="1"/>
           <p:nvPr/>
         </p:nvSpPr>
@@ -6779,7 +6802,7 @@
       </p:sp>
       <p:sp>
         <p:nvSpPr>
-          <p:cNvPr id="44" name="TextBox 43"/>
+          <p:cNvPr id="45" name="TextBox 44"/>
           <p:cNvSpPr txBox="1"/>
           <p:nvPr/>
         </p:nvSpPr>
@@ -6902,7 +6925,7 @@
       </p:sp>
       <p:sp>
         <p:nvSpPr>
-          <p:cNvPr id="45" name="Rectangle 44"/>
+          <p:cNvPr id="46" name="Rectangle 45"/>
           <p:cNvSpPr/>
           <p:nvPr/>
         </p:nvSpPr>
@@ -6963,7 +6986,7 @@
       </p:sp>
       <p:sp>
         <p:nvSpPr>
-          <p:cNvPr id="46" name="Rectangle 45"/>
+          <p:cNvPr id="47" name="Rectangle 46"/>
           <p:cNvSpPr/>
           <p:nvPr/>
         </p:nvSpPr>
@@ -7024,7 +7047,7 @@
       </p:sp>
       <p:sp>
         <p:nvSpPr>
-          <p:cNvPr id="47" name="Rectangle 46"/>
+          <p:cNvPr id="48" name="Rectangle 47"/>
           <p:cNvSpPr/>
           <p:nvPr/>
         </p:nvSpPr>
@@ -7068,7 +7091,7 @@
       </p:sp>
       <p:sp>
         <p:nvSpPr>
-          <p:cNvPr id="48" name="Oval 47"/>
+          <p:cNvPr id="49" name="Oval 48"/>
           <p:cNvSpPr/>
           <p:nvPr/>
         </p:nvSpPr>
@@ -7131,7 +7154,7 @@
       </p:sp>
       <p:sp>
         <p:nvSpPr>
-          <p:cNvPr id="49" name="TextBox 48"/>
+          <p:cNvPr id="50" name="TextBox 49"/>
           <p:cNvSpPr txBox="1"/>
           <p:nvPr/>
         </p:nvSpPr>
@@ -7274,7 +7297,7 @@
       </p:sp>
       <p:sp>
         <p:nvSpPr>
-          <p:cNvPr id="50" name="Oval 49"/>
+          <p:cNvPr id="51" name="Oval 50"/>
           <p:cNvSpPr/>
           <p:nvPr/>
         </p:nvSpPr>
@@ -7337,7 +7360,7 @@
       </p:sp>
       <p:sp>
         <p:nvSpPr>
-          <p:cNvPr id="51" name="TextBox 50"/>
+          <p:cNvPr id="52" name="TextBox 51"/>
           <p:cNvSpPr txBox="1"/>
           <p:nvPr/>
         </p:nvSpPr>
@@ -7460,7 +7483,7 @@
       </p:sp>
       <p:sp>
         <p:nvSpPr>
-          <p:cNvPr id="52" name="Oval 51"/>
+          <p:cNvPr id="53" name="Oval 52"/>
           <p:cNvSpPr/>
           <p:nvPr/>
         </p:nvSpPr>
@@ -7523,7 +7546,7 @@
       </p:sp>
       <p:sp>
         <p:nvSpPr>
-          <p:cNvPr id="53" name="TextBox 52"/>
+          <p:cNvPr id="54" name="TextBox 53"/>
           <p:cNvSpPr txBox="1"/>
           <p:nvPr/>
         </p:nvSpPr>
@@ -7646,7 +7669,7 @@
       </p:sp>
       <p:sp>
         <p:nvSpPr>
-          <p:cNvPr id="54" name="Oval 53"/>
+          <p:cNvPr id="55" name="Oval 54"/>
           <p:cNvSpPr/>
           <p:nvPr/>
         </p:nvSpPr>
@@ -7709,7 +7732,7 @@
       </p:sp>
       <p:sp>
         <p:nvSpPr>
-          <p:cNvPr id="55" name="TextBox 54"/>
+          <p:cNvPr id="56" name="TextBox 55"/>
           <p:cNvSpPr txBox="1"/>
           <p:nvPr/>
         </p:nvSpPr>
@@ -7812,7 +7835,7 @@
       </p:sp>
       <p:sp>
         <p:nvSpPr>
-          <p:cNvPr id="56" name="TextBox 55"/>
+          <p:cNvPr id="57" name="TextBox 56"/>
           <p:cNvSpPr txBox="1"/>
           <p:nvPr/>
         </p:nvSpPr>

</xml_diff>